<commit_message>
Some addition to Monitoring and Security
</commit_message>
<xml_diff>
--- a/AKS_DD_Monitoring.pptx
+++ b/AKS_DD_Monitoring.pptx
@@ -5,7 +5,7 @@
     <p:sldMasterId id="2147483660" r:id="rId1"/>
   </p:sldMasterIdLst>
   <p:notesMasterIdLst>
-    <p:notesMasterId r:id="rId11"/>
+    <p:notesMasterId r:id="rId12"/>
   </p:notesMasterIdLst>
   <p:sldIdLst>
     <p:sldId id="256" r:id="rId2"/>
@@ -16,7 +16,8 @@
     <p:sldId id="279" r:id="rId7"/>
     <p:sldId id="369" r:id="rId8"/>
     <p:sldId id="334" r:id="rId9"/>
-    <p:sldId id="335" r:id="rId10"/>
+    <p:sldId id="370" r:id="rId10"/>
+    <p:sldId id="335" r:id="rId11"/>
   </p:sldIdLst>
   <p:sldSz cx="12192000" cy="6858000"/>
   <p:notesSz cx="6858000" cy="9144000"/>
@@ -123,10 +124,16 @@
 </p:presentation>
 </file>
 
+<file path=ppt/authors.xml><?xml version="1.0" encoding="utf-8"?>
+<p188:authorLst xmlns:a="http://schemas.openxmlformats.org/drawingml/2006/main" xmlns:r="http://schemas.openxmlformats.org/officeDocument/2006/relationships" xmlns:p188="http://schemas.microsoft.com/office/powerpoint/2018/8/main">
+  <p188:author id="{02202E6B-3C7E-3268-10A6-359B82E53773}" name="Aritra Ghosh" initials="AG" userId="S::aritraghosh@microsoft.com::dce1d2a3-e29a-4161-a043-6e04439884c1" providerId="AD"/>
+</p188:authorLst>
+</file>
+
 <file path=ppt/revisionInfo.xml><?xml version="1.0" encoding="utf-8"?>
 <p1510:revInfo xmlns:a="http://schemas.openxmlformats.org/drawingml/2006/main" xmlns:r="http://schemas.openxmlformats.org/officeDocument/2006/relationships" xmlns:p1510="http://schemas.microsoft.com/office/powerpoint/2015/10/main">
   <p1510:revLst>
-    <p1510:client id="{CCC53F32-0E14-4DA3-AD7D-C703B44DF16D}" v="10" dt="2026-02-04T21:12:03.891"/>
+    <p1510:client id="{33CDD246-981A-4F17-923F-0E3ECDAEDCE2}" v="2" dt="2026-02-23T19:01:00.444"/>
   </p1510:revLst>
 </p1510:revInfo>
 </file>
@@ -135,219 +142,38 @@
 <pc:chgInfo xmlns:a="http://schemas.openxmlformats.org/drawingml/2006/main" xmlns:r="http://schemas.openxmlformats.org/officeDocument/2006/relationships" xmlns:ac="http://schemas.microsoft.com/office/drawing/2013/main/command" xmlns:pc="http://schemas.microsoft.com/office/powerpoint/2013/main/command">
   <pc:docChgLst>
     <pc:chgData name="faik bilgen" userId="9fcb1696e65a161f" providerId="LiveId" clId="{0C3A4C9E-717D-4ADE-97E0-B0AD580B3355}"/>
-    <pc:docChg chg="undo custSel addSld delSld modSld sldOrd">
-      <pc:chgData name="faik bilgen" userId="9fcb1696e65a161f" providerId="LiveId" clId="{0C3A4C9E-717D-4ADE-97E0-B0AD580B3355}" dt="2026-02-04T21:12:25.177" v="5800" actId="20577"/>
+    <pc:docChg chg="undo custSel addSld delSld modSld sldOrd delMainMaster">
+      <pc:chgData name="faik bilgen" userId="9fcb1696e65a161f" providerId="LiveId" clId="{0C3A4C9E-717D-4ADE-97E0-B0AD580B3355}" dt="2026-02-25T14:04:07.475" v="5811" actId="47"/>
       <pc:docMkLst>
         <pc:docMk/>
       </pc:docMkLst>
+      <pc:sldChg chg="add del">
+        <pc:chgData name="faik bilgen" userId="9fcb1696e65a161f" providerId="LiveId" clId="{0C3A4C9E-717D-4ADE-97E0-B0AD580B3355}" dt="2026-02-25T14:04:07.475" v="5811" actId="47"/>
+        <pc:sldMkLst>
+          <pc:docMk/>
+          <pc:sldMk cId="1209355792" sldId="266"/>
+        </pc:sldMkLst>
+      </pc:sldChg>
+      <pc:sldChg chg="add del">
+        <pc:chgData name="faik bilgen" userId="9fcb1696e65a161f" providerId="LiveId" clId="{0C3A4C9E-717D-4ADE-97E0-B0AD580B3355}" dt="2026-02-25T14:04:06.474" v="5810" actId="47"/>
+        <pc:sldMkLst>
+          <pc:docMk/>
+          <pc:sldMk cId="676354330" sldId="267"/>
+        </pc:sldMkLst>
+      </pc:sldChg>
+      <pc:sldChg chg="add del">
+        <pc:chgData name="faik bilgen" userId="9fcb1696e65a161f" providerId="LiveId" clId="{0C3A4C9E-717D-4ADE-97E0-B0AD580B3355}" dt="2026-02-25T14:04:05.630" v="5809" actId="47"/>
+        <pc:sldMkLst>
+          <pc:docMk/>
+          <pc:sldMk cId="4028145312" sldId="268"/>
+        </pc:sldMkLst>
+      </pc:sldChg>
       <pc:sldChg chg="modSp add mod ord modNotesTx">
         <pc:chgData name="faik bilgen" userId="9fcb1696e65a161f" providerId="LiveId" clId="{0C3A4C9E-717D-4ADE-97E0-B0AD580B3355}" dt="2026-02-01T11:40:50.413" v="5790"/>
         <pc:sldMkLst>
           <pc:docMk/>
           <pc:sldMk cId="2540744057" sldId="279"/>
         </pc:sldMkLst>
-        <pc:spChg chg="mod">
-          <ac:chgData name="faik bilgen" userId="9fcb1696e65a161f" providerId="LiveId" clId="{0C3A4C9E-717D-4ADE-97E0-B0AD580B3355}" dt="2026-01-20T08:56:23.035" v="5626" actId="20577"/>
-          <ac:spMkLst>
-            <pc:docMk/>
-            <pc:sldMk cId="2540744057" sldId="279"/>
-            <ac:spMk id="3" creationId="{ABE0EBD9-543C-DF01-01FB-128713202535}"/>
-          </ac:spMkLst>
-        </pc:spChg>
-      </pc:sldChg>
-      <pc:sldChg chg="modSp mod">
-        <pc:chgData name="faik bilgen" userId="9fcb1696e65a161f" providerId="LiveId" clId="{0C3A4C9E-717D-4ADE-97E0-B0AD580B3355}" dt="2026-01-19T13:51:33.437" v="5595" actId="20577"/>
-        <pc:sldMkLst>
-          <pc:docMk/>
-          <pc:sldMk cId="4292313360" sldId="282"/>
-        </pc:sldMkLst>
-        <pc:spChg chg="mod">
-          <ac:chgData name="faik bilgen" userId="9fcb1696e65a161f" providerId="LiveId" clId="{0C3A4C9E-717D-4ADE-97E0-B0AD580B3355}" dt="2026-01-19T13:51:33.437" v="5595" actId="20577"/>
-          <ac:spMkLst>
-            <pc:docMk/>
-            <pc:sldMk cId="4292313360" sldId="282"/>
-            <ac:spMk id="2" creationId="{DD27CCCF-AE7A-25E7-BFFF-0DA25929D339}"/>
-          </ac:spMkLst>
-        </pc:spChg>
-      </pc:sldChg>
-      <pc:sldChg chg="addSp delSp modSp new mod setBg">
-        <pc:chgData name="faik bilgen" userId="9fcb1696e65a161f" providerId="LiveId" clId="{0C3A4C9E-717D-4ADE-97E0-B0AD580B3355}" dt="2026-01-17T12:38:38.133" v="4157" actId="26606"/>
-        <pc:sldMkLst>
-          <pc:docMk/>
-          <pc:sldMk cId="1936368771" sldId="334"/>
-        </pc:sldMkLst>
-        <pc:spChg chg="mod">
-          <ac:chgData name="faik bilgen" userId="9fcb1696e65a161f" providerId="LiveId" clId="{0C3A4C9E-717D-4ADE-97E0-B0AD580B3355}" dt="2026-01-17T12:38:38.133" v="4157" actId="26606"/>
-          <ac:spMkLst>
-            <pc:docMk/>
-            <pc:sldMk cId="1936368771" sldId="334"/>
-            <ac:spMk id="3" creationId="{354F4E26-D1F3-EC07-4782-463CFD06FAD1}"/>
-          </ac:spMkLst>
-        </pc:spChg>
-        <pc:spChg chg="add">
-          <ac:chgData name="faik bilgen" userId="9fcb1696e65a161f" providerId="LiveId" clId="{0C3A4C9E-717D-4ADE-97E0-B0AD580B3355}" dt="2026-01-17T12:38:38.133" v="4157" actId="26606"/>
-          <ac:spMkLst>
-            <pc:docMk/>
-            <pc:sldMk cId="1936368771" sldId="334"/>
-            <ac:spMk id="24" creationId="{389575E1-3389-451A-A5F7-27854C25C599}"/>
-          </ac:spMkLst>
-        </pc:spChg>
-        <pc:spChg chg="add">
-          <ac:chgData name="faik bilgen" userId="9fcb1696e65a161f" providerId="LiveId" clId="{0C3A4C9E-717D-4ADE-97E0-B0AD580B3355}" dt="2026-01-17T12:38:38.133" v="4157" actId="26606"/>
-          <ac:spMkLst>
-            <pc:docMk/>
-            <pc:sldMk cId="1936368771" sldId="334"/>
-            <ac:spMk id="25" creationId="{A53CCC5C-D88E-40FB-B30B-23DCDBD01D37}"/>
-          </ac:spMkLst>
-        </pc:spChg>
-        <pc:spChg chg="add">
-          <ac:chgData name="faik bilgen" userId="9fcb1696e65a161f" providerId="LiveId" clId="{0C3A4C9E-717D-4ADE-97E0-B0AD580B3355}" dt="2026-01-17T12:38:38.133" v="4157" actId="26606"/>
-          <ac:spMkLst>
-            <pc:docMk/>
-            <pc:sldMk cId="1936368771" sldId="334"/>
-            <ac:spMk id="26" creationId="{081E4A58-353D-44AE-B2FC-2A74E2E400F7}"/>
-          </ac:spMkLst>
-        </pc:spChg>
-      </pc:sldChg>
-      <pc:sldChg chg="modSp add mod">
-        <pc:chgData name="faik bilgen" userId="9fcb1696e65a161f" providerId="LiveId" clId="{0C3A4C9E-717D-4ADE-97E0-B0AD580B3355}" dt="2026-01-17T12:39:00.985" v="4167" actId="20577"/>
-        <pc:sldMkLst>
-          <pc:docMk/>
-          <pc:sldMk cId="1409184322" sldId="335"/>
-        </pc:sldMkLst>
-        <pc:spChg chg="mod">
-          <ac:chgData name="faik bilgen" userId="9fcb1696e65a161f" providerId="LiveId" clId="{0C3A4C9E-717D-4ADE-97E0-B0AD580B3355}" dt="2026-01-17T12:39:00.985" v="4167" actId="20577"/>
-          <ac:spMkLst>
-            <pc:docMk/>
-            <pc:sldMk cId="1409184322" sldId="335"/>
-            <ac:spMk id="3" creationId="{19BE6953-44A8-E351-F8C5-9B2D6522B55D}"/>
-          </ac:spMkLst>
-        </pc:spChg>
-      </pc:sldChg>
-      <pc:sldChg chg="addSp delSp modSp new mod setBg">
-        <pc:chgData name="faik bilgen" userId="9fcb1696e65a161f" providerId="LiveId" clId="{0C3A4C9E-717D-4ADE-97E0-B0AD580B3355}" dt="2026-01-20T11:25:24.318" v="5772" actId="14100"/>
-        <pc:sldMkLst>
-          <pc:docMk/>
-          <pc:sldMk cId="4272325911" sldId="366"/>
-        </pc:sldMkLst>
-        <pc:spChg chg="mod">
-          <ac:chgData name="faik bilgen" userId="9fcb1696e65a161f" providerId="LiveId" clId="{0C3A4C9E-717D-4ADE-97E0-B0AD580B3355}" dt="2026-01-20T11:25:14.399" v="5770" actId="26606"/>
-          <ac:spMkLst>
-            <pc:docMk/>
-            <pc:sldMk cId="4272325911" sldId="366"/>
-            <ac:spMk id="2" creationId="{E6A3B6DF-B8D5-762F-5501-C7BA79361C20}"/>
-          </ac:spMkLst>
-        </pc:spChg>
-        <pc:spChg chg="add">
-          <ac:chgData name="faik bilgen" userId="9fcb1696e65a161f" providerId="LiveId" clId="{0C3A4C9E-717D-4ADE-97E0-B0AD580B3355}" dt="2026-01-20T11:25:14.399" v="5770" actId="26606"/>
-          <ac:spMkLst>
-            <pc:docMk/>
-            <pc:sldMk cId="4272325911" sldId="366"/>
-            <ac:spMk id="10" creationId="{BCED4D40-4B67-4331-AC48-79B82B4A47D8}"/>
-          </ac:spMkLst>
-        </pc:spChg>
-        <pc:spChg chg="add">
-          <ac:chgData name="faik bilgen" userId="9fcb1696e65a161f" providerId="LiveId" clId="{0C3A4C9E-717D-4ADE-97E0-B0AD580B3355}" dt="2026-01-20T11:25:14.399" v="5770" actId="26606"/>
-          <ac:spMkLst>
-            <pc:docMk/>
-            <pc:sldMk cId="4272325911" sldId="366"/>
-            <ac:spMk id="12" creationId="{670CEDEF-4F34-412E-84EE-329C1E936AF5}"/>
-          </ac:spMkLst>
-        </pc:spChg>
-        <pc:picChg chg="add mod">
-          <ac:chgData name="faik bilgen" userId="9fcb1696e65a161f" providerId="LiveId" clId="{0C3A4C9E-717D-4ADE-97E0-B0AD580B3355}" dt="2026-01-20T11:25:24.318" v="5772" actId="14100"/>
-          <ac:picMkLst>
-            <pc:docMk/>
-            <pc:sldMk cId="4272325911" sldId="366"/>
-            <ac:picMk id="5" creationId="{4DA1FECF-1482-2930-B9D1-1A2D93C0F6A0}"/>
-          </ac:picMkLst>
-        </pc:picChg>
-      </pc:sldChg>
-      <pc:sldChg chg="addSp delSp modSp add mod setBg">
-        <pc:chgData name="faik bilgen" userId="9fcb1696e65a161f" providerId="LiveId" clId="{0C3A4C9E-717D-4ADE-97E0-B0AD580B3355}" dt="2026-01-20T11:26:44.562" v="5780" actId="26606"/>
-        <pc:sldMkLst>
-          <pc:docMk/>
-          <pc:sldMk cId="1519829562" sldId="367"/>
-        </pc:sldMkLst>
-        <pc:spChg chg="mod">
-          <ac:chgData name="faik bilgen" userId="9fcb1696e65a161f" providerId="LiveId" clId="{0C3A4C9E-717D-4ADE-97E0-B0AD580B3355}" dt="2026-01-20T11:26:44.562" v="5780" actId="26606"/>
-          <ac:spMkLst>
-            <pc:docMk/>
-            <pc:sldMk cId="1519829562" sldId="367"/>
-            <ac:spMk id="2" creationId="{362F0C08-2DC4-B486-C525-6E8C1E9DDE54}"/>
-          </ac:spMkLst>
-        </pc:spChg>
-        <pc:spChg chg="add mod">
-          <ac:chgData name="faik bilgen" userId="9fcb1696e65a161f" providerId="LiveId" clId="{0C3A4C9E-717D-4ADE-97E0-B0AD580B3355}" dt="2026-01-20T11:26:44.562" v="5780" actId="26606"/>
-          <ac:spMkLst>
-            <pc:docMk/>
-            <pc:sldMk cId="1519829562" sldId="367"/>
-            <ac:spMk id="3" creationId="{F9ED8474-27A4-43FC-F3A4-D690C64CED01}"/>
-          </ac:spMkLst>
-        </pc:spChg>
-        <pc:spChg chg="add">
-          <ac:chgData name="faik bilgen" userId="9fcb1696e65a161f" providerId="LiveId" clId="{0C3A4C9E-717D-4ADE-97E0-B0AD580B3355}" dt="2026-01-20T11:26:44.562" v="5780" actId="26606"/>
-          <ac:spMkLst>
-            <pc:docMk/>
-            <pc:sldMk cId="1519829562" sldId="367"/>
-            <ac:spMk id="9" creationId="{C0763A76-9F1C-4FC5-82B7-DD475DA461B2}"/>
-          </ac:spMkLst>
-        </pc:spChg>
-        <pc:spChg chg="add">
-          <ac:chgData name="faik bilgen" userId="9fcb1696e65a161f" providerId="LiveId" clId="{0C3A4C9E-717D-4ADE-97E0-B0AD580B3355}" dt="2026-01-20T11:26:44.562" v="5780" actId="26606"/>
-          <ac:spMkLst>
-            <pc:docMk/>
-            <pc:sldMk cId="1519829562" sldId="367"/>
-            <ac:spMk id="11" creationId="{E81BF4F6-F2CF-4984-9D14-D6966D92F99F}"/>
-          </ac:spMkLst>
-        </pc:spChg>
-        <pc:picChg chg="add">
-          <ac:chgData name="faik bilgen" userId="9fcb1696e65a161f" providerId="LiveId" clId="{0C3A4C9E-717D-4ADE-97E0-B0AD580B3355}" dt="2026-01-20T11:26:44.562" v="5780" actId="26606"/>
-          <ac:picMkLst>
-            <pc:docMk/>
-            <pc:sldMk cId="1519829562" sldId="367"/>
-            <ac:picMk id="6" creationId="{9E941563-7411-F599-8F03-11ABE86B4EE4}"/>
-          </ac:picMkLst>
-        </pc:picChg>
-      </pc:sldChg>
-      <pc:sldChg chg="addSp delSp modSp add mod setBg">
-        <pc:chgData name="faik bilgen" userId="9fcb1696e65a161f" providerId="LiveId" clId="{0C3A4C9E-717D-4ADE-97E0-B0AD580B3355}" dt="2026-01-20T11:26:34.319" v="5779" actId="1076"/>
-        <pc:sldMkLst>
-          <pc:docMk/>
-          <pc:sldMk cId="2727749857" sldId="368"/>
-        </pc:sldMkLst>
-        <pc:spChg chg="mod">
-          <ac:chgData name="faik bilgen" userId="9fcb1696e65a161f" providerId="LiveId" clId="{0C3A4C9E-717D-4ADE-97E0-B0AD580B3355}" dt="2026-01-20T11:26:24.511" v="5777" actId="26606"/>
-          <ac:spMkLst>
-            <pc:docMk/>
-            <pc:sldMk cId="2727749857" sldId="368"/>
-            <ac:spMk id="2" creationId="{39654F24-926C-5FC1-CB8F-7C4218C1AB17}"/>
-          </ac:spMkLst>
-        </pc:spChg>
-        <pc:spChg chg="add">
-          <ac:chgData name="faik bilgen" userId="9fcb1696e65a161f" providerId="LiveId" clId="{0C3A4C9E-717D-4ADE-97E0-B0AD580B3355}" dt="2026-01-20T11:26:24.511" v="5777" actId="26606"/>
-          <ac:spMkLst>
-            <pc:docMk/>
-            <pc:sldMk cId="2727749857" sldId="368"/>
-            <ac:spMk id="15" creationId="{BCED4D40-4B67-4331-AC48-79B82B4A47D8}"/>
-          </ac:spMkLst>
-        </pc:spChg>
-        <pc:spChg chg="add">
-          <ac:chgData name="faik bilgen" userId="9fcb1696e65a161f" providerId="LiveId" clId="{0C3A4C9E-717D-4ADE-97E0-B0AD580B3355}" dt="2026-01-20T11:26:24.511" v="5777" actId="26606"/>
-          <ac:spMkLst>
-            <pc:docMk/>
-            <pc:sldMk cId="2727749857" sldId="368"/>
-            <ac:spMk id="16" creationId="{670CEDEF-4F34-412E-84EE-329C1E936AF5}"/>
-          </ac:spMkLst>
-        </pc:spChg>
-        <pc:picChg chg="add mod">
-          <ac:chgData name="faik bilgen" userId="9fcb1696e65a161f" providerId="LiveId" clId="{0C3A4C9E-717D-4ADE-97E0-B0AD580B3355}" dt="2026-01-20T11:26:34.319" v="5779" actId="1076"/>
-          <ac:picMkLst>
-            <pc:docMk/>
-            <pc:sldMk cId="2727749857" sldId="368"/>
-            <ac:picMk id="3" creationId="{E31D764E-E440-96DC-BA93-CAC22A0DB4BF}"/>
-          </ac:picMkLst>
-        </pc:picChg>
       </pc:sldChg>
       <pc:sldChg chg="modSp add mod ord modNotesTx">
         <pc:chgData name="faik bilgen" userId="9fcb1696e65a161f" providerId="LiveId" clId="{0C3A4C9E-717D-4ADE-97E0-B0AD580B3355}" dt="2026-02-04T21:12:25.177" v="5800" actId="20577"/>
@@ -364,6 +190,731 @@
           </ac:spMkLst>
         </pc:spChg>
       </pc:sldChg>
+      <pc:sldChg chg="addSp delSp modSp new mod">
+        <pc:chgData name="faik bilgen" userId="9fcb1696e65a161f" providerId="LiveId" clId="{0C3A4C9E-717D-4ADE-97E0-B0AD580B3355}" dt="2026-02-25T09:10:00.341" v="5808" actId="1076"/>
+        <pc:sldMkLst>
+          <pc:docMk/>
+          <pc:sldMk cId="1002164974" sldId="370"/>
+        </pc:sldMkLst>
+        <pc:spChg chg="del">
+          <ac:chgData name="faik bilgen" userId="9fcb1696e65a161f" providerId="LiveId" clId="{0C3A4C9E-717D-4ADE-97E0-B0AD580B3355}" dt="2026-02-25T09:09:48.261" v="5805" actId="478"/>
+          <ac:spMkLst>
+            <pc:docMk/>
+            <pc:sldMk cId="1002164974" sldId="370"/>
+            <ac:spMk id="2" creationId="{B0467B65-D183-93F5-FF6A-B5BA52B59B88}"/>
+          </ac:spMkLst>
+        </pc:spChg>
+        <pc:spChg chg="del">
+          <ac:chgData name="faik bilgen" userId="9fcb1696e65a161f" providerId="LiveId" clId="{0C3A4C9E-717D-4ADE-97E0-B0AD580B3355}" dt="2026-02-25T09:09:53.069" v="5806" actId="478"/>
+          <ac:spMkLst>
+            <pc:docMk/>
+            <pc:sldMk cId="1002164974" sldId="370"/>
+            <ac:spMk id="3" creationId="{4BFD2359-67C3-117C-E8FB-E2165EB23B7A}"/>
+          </ac:spMkLst>
+        </pc:spChg>
+        <pc:spChg chg="add mod">
+          <ac:chgData name="faik bilgen" userId="9fcb1696e65a161f" providerId="LiveId" clId="{0C3A4C9E-717D-4ADE-97E0-B0AD580B3355}" dt="2026-02-25T09:10:00.341" v="5808" actId="1076"/>
+          <ac:spMkLst>
+            <pc:docMk/>
+            <pc:sldMk cId="1002164974" sldId="370"/>
+            <ac:spMk id="5" creationId="{C7CC2621-CD84-C051-182F-C0B593923FCE}"/>
+          </ac:spMkLst>
+        </pc:spChg>
+      </pc:sldChg>
+      <pc:sldChg chg="new del">
+        <pc:chgData name="faik bilgen" userId="9fcb1696e65a161f" providerId="LiveId" clId="{0C3A4C9E-717D-4ADE-97E0-B0AD580B3355}" dt="2026-02-25T09:09:41.338" v="5803" actId="47"/>
+        <pc:sldMkLst>
+          <pc:docMk/>
+          <pc:sldMk cId="3746520061" sldId="370"/>
+        </pc:sldMkLst>
+      </pc:sldChg>
+      <pc:sldMasterChg chg="del delSldLayout">
+        <pc:chgData name="faik bilgen" userId="9fcb1696e65a161f" providerId="LiveId" clId="{0C3A4C9E-717D-4ADE-97E0-B0AD580B3355}" dt="2026-02-25T14:04:07.475" v="5811" actId="47"/>
+        <pc:sldMasterMkLst>
+          <pc:docMk/>
+          <pc:sldMasterMk cId="383322428" sldId="2147483672"/>
+        </pc:sldMasterMkLst>
+        <pc:sldLayoutChg chg="del">
+          <pc:chgData name="faik bilgen" userId="9fcb1696e65a161f" providerId="LiveId" clId="{0C3A4C9E-717D-4ADE-97E0-B0AD580B3355}" dt="2026-02-25T14:04:07.475" v="5811" actId="47"/>
+          <pc:sldLayoutMkLst>
+            <pc:docMk/>
+            <pc:sldMasterMk cId="383322428" sldId="2147483672"/>
+            <pc:sldLayoutMk cId="754427399" sldId="2147483673"/>
+          </pc:sldLayoutMkLst>
+        </pc:sldLayoutChg>
+        <pc:sldLayoutChg chg="del">
+          <pc:chgData name="faik bilgen" userId="9fcb1696e65a161f" providerId="LiveId" clId="{0C3A4C9E-717D-4ADE-97E0-B0AD580B3355}" dt="2026-02-25T14:04:07.475" v="5811" actId="47"/>
+          <pc:sldLayoutMkLst>
+            <pc:docMk/>
+            <pc:sldMasterMk cId="383322428" sldId="2147483672"/>
+            <pc:sldLayoutMk cId="3246322079" sldId="2147483674"/>
+          </pc:sldLayoutMkLst>
+        </pc:sldLayoutChg>
+        <pc:sldLayoutChg chg="del">
+          <pc:chgData name="faik bilgen" userId="9fcb1696e65a161f" providerId="LiveId" clId="{0C3A4C9E-717D-4ADE-97E0-B0AD580B3355}" dt="2026-02-25T14:04:07.475" v="5811" actId="47"/>
+          <pc:sldLayoutMkLst>
+            <pc:docMk/>
+            <pc:sldMasterMk cId="383322428" sldId="2147483672"/>
+            <pc:sldLayoutMk cId="465842836" sldId="2147483675"/>
+          </pc:sldLayoutMkLst>
+        </pc:sldLayoutChg>
+        <pc:sldLayoutChg chg="del">
+          <pc:chgData name="faik bilgen" userId="9fcb1696e65a161f" providerId="LiveId" clId="{0C3A4C9E-717D-4ADE-97E0-B0AD580B3355}" dt="2026-02-25T14:04:07.475" v="5811" actId="47"/>
+          <pc:sldLayoutMkLst>
+            <pc:docMk/>
+            <pc:sldMasterMk cId="383322428" sldId="2147483672"/>
+            <pc:sldLayoutMk cId="220474910" sldId="2147483676"/>
+          </pc:sldLayoutMkLst>
+        </pc:sldLayoutChg>
+        <pc:sldLayoutChg chg="del">
+          <pc:chgData name="faik bilgen" userId="9fcb1696e65a161f" providerId="LiveId" clId="{0C3A4C9E-717D-4ADE-97E0-B0AD580B3355}" dt="2026-02-25T14:04:07.475" v="5811" actId="47"/>
+          <pc:sldLayoutMkLst>
+            <pc:docMk/>
+            <pc:sldMasterMk cId="383322428" sldId="2147483672"/>
+            <pc:sldLayoutMk cId="4119388763" sldId="2147483677"/>
+          </pc:sldLayoutMkLst>
+        </pc:sldLayoutChg>
+        <pc:sldLayoutChg chg="del">
+          <pc:chgData name="faik bilgen" userId="9fcb1696e65a161f" providerId="LiveId" clId="{0C3A4C9E-717D-4ADE-97E0-B0AD580B3355}" dt="2026-02-25T14:04:07.475" v="5811" actId="47"/>
+          <pc:sldLayoutMkLst>
+            <pc:docMk/>
+            <pc:sldMasterMk cId="383322428" sldId="2147483672"/>
+            <pc:sldLayoutMk cId="3258328004" sldId="2147483678"/>
+          </pc:sldLayoutMkLst>
+        </pc:sldLayoutChg>
+        <pc:sldLayoutChg chg="del">
+          <pc:chgData name="faik bilgen" userId="9fcb1696e65a161f" providerId="LiveId" clId="{0C3A4C9E-717D-4ADE-97E0-B0AD580B3355}" dt="2026-02-25T14:04:07.475" v="5811" actId="47"/>
+          <pc:sldLayoutMkLst>
+            <pc:docMk/>
+            <pc:sldMasterMk cId="383322428" sldId="2147483672"/>
+            <pc:sldLayoutMk cId="3435838346" sldId="2147483679"/>
+          </pc:sldLayoutMkLst>
+        </pc:sldLayoutChg>
+        <pc:sldLayoutChg chg="del">
+          <pc:chgData name="faik bilgen" userId="9fcb1696e65a161f" providerId="LiveId" clId="{0C3A4C9E-717D-4ADE-97E0-B0AD580B3355}" dt="2026-02-25T14:04:07.475" v="5811" actId="47"/>
+          <pc:sldLayoutMkLst>
+            <pc:docMk/>
+            <pc:sldMasterMk cId="383322428" sldId="2147483672"/>
+            <pc:sldLayoutMk cId="2638759515" sldId="2147483680"/>
+          </pc:sldLayoutMkLst>
+        </pc:sldLayoutChg>
+        <pc:sldLayoutChg chg="del">
+          <pc:chgData name="faik bilgen" userId="9fcb1696e65a161f" providerId="LiveId" clId="{0C3A4C9E-717D-4ADE-97E0-B0AD580B3355}" dt="2026-02-25T14:04:07.475" v="5811" actId="47"/>
+          <pc:sldLayoutMkLst>
+            <pc:docMk/>
+            <pc:sldMasterMk cId="383322428" sldId="2147483672"/>
+            <pc:sldLayoutMk cId="2324943517" sldId="2147483681"/>
+          </pc:sldLayoutMkLst>
+        </pc:sldLayoutChg>
+        <pc:sldLayoutChg chg="del">
+          <pc:chgData name="faik bilgen" userId="9fcb1696e65a161f" providerId="LiveId" clId="{0C3A4C9E-717D-4ADE-97E0-B0AD580B3355}" dt="2026-02-25T14:04:07.475" v="5811" actId="47"/>
+          <pc:sldLayoutMkLst>
+            <pc:docMk/>
+            <pc:sldMasterMk cId="383322428" sldId="2147483672"/>
+            <pc:sldLayoutMk cId="1416883766" sldId="2147483682"/>
+          </pc:sldLayoutMkLst>
+        </pc:sldLayoutChg>
+        <pc:sldLayoutChg chg="del">
+          <pc:chgData name="faik bilgen" userId="9fcb1696e65a161f" providerId="LiveId" clId="{0C3A4C9E-717D-4ADE-97E0-B0AD580B3355}" dt="2026-02-25T14:04:07.475" v="5811" actId="47"/>
+          <pc:sldLayoutMkLst>
+            <pc:docMk/>
+            <pc:sldMasterMk cId="383322428" sldId="2147483672"/>
+            <pc:sldLayoutMk cId="4229714183" sldId="2147483683"/>
+          </pc:sldLayoutMkLst>
+        </pc:sldLayoutChg>
+        <pc:sldLayoutChg chg="del">
+          <pc:chgData name="faik bilgen" userId="9fcb1696e65a161f" providerId="LiveId" clId="{0C3A4C9E-717D-4ADE-97E0-B0AD580B3355}" dt="2026-02-25T14:04:07.475" v="5811" actId="47"/>
+          <pc:sldLayoutMkLst>
+            <pc:docMk/>
+            <pc:sldMasterMk cId="383322428" sldId="2147483672"/>
+            <pc:sldLayoutMk cId="1997332745" sldId="2147483684"/>
+          </pc:sldLayoutMkLst>
+        </pc:sldLayoutChg>
+        <pc:sldLayoutChg chg="del">
+          <pc:chgData name="faik bilgen" userId="9fcb1696e65a161f" providerId="LiveId" clId="{0C3A4C9E-717D-4ADE-97E0-B0AD580B3355}" dt="2026-02-25T14:04:07.475" v="5811" actId="47"/>
+          <pc:sldLayoutMkLst>
+            <pc:docMk/>
+            <pc:sldMasterMk cId="383322428" sldId="2147483672"/>
+            <pc:sldLayoutMk cId="3590210439" sldId="2147483685"/>
+          </pc:sldLayoutMkLst>
+        </pc:sldLayoutChg>
+        <pc:sldLayoutChg chg="del">
+          <pc:chgData name="faik bilgen" userId="9fcb1696e65a161f" providerId="LiveId" clId="{0C3A4C9E-717D-4ADE-97E0-B0AD580B3355}" dt="2026-02-25T14:04:07.475" v="5811" actId="47"/>
+          <pc:sldLayoutMkLst>
+            <pc:docMk/>
+            <pc:sldMasterMk cId="383322428" sldId="2147483672"/>
+            <pc:sldLayoutMk cId="1248685454" sldId="2147483686"/>
+          </pc:sldLayoutMkLst>
+        </pc:sldLayoutChg>
+        <pc:sldLayoutChg chg="del">
+          <pc:chgData name="faik bilgen" userId="9fcb1696e65a161f" providerId="LiveId" clId="{0C3A4C9E-717D-4ADE-97E0-B0AD580B3355}" dt="2026-02-25T14:04:07.475" v="5811" actId="47"/>
+          <pc:sldLayoutMkLst>
+            <pc:docMk/>
+            <pc:sldMasterMk cId="383322428" sldId="2147483672"/>
+            <pc:sldLayoutMk cId="1687918517" sldId="2147483687"/>
+          </pc:sldLayoutMkLst>
+        </pc:sldLayoutChg>
+        <pc:sldLayoutChg chg="del">
+          <pc:chgData name="faik bilgen" userId="9fcb1696e65a161f" providerId="LiveId" clId="{0C3A4C9E-717D-4ADE-97E0-B0AD580B3355}" dt="2026-02-25T14:04:07.475" v="5811" actId="47"/>
+          <pc:sldLayoutMkLst>
+            <pc:docMk/>
+            <pc:sldMasterMk cId="383322428" sldId="2147483672"/>
+            <pc:sldLayoutMk cId="2499866034" sldId="2147483688"/>
+          </pc:sldLayoutMkLst>
+        </pc:sldLayoutChg>
+        <pc:sldLayoutChg chg="del">
+          <pc:chgData name="faik bilgen" userId="9fcb1696e65a161f" providerId="LiveId" clId="{0C3A4C9E-717D-4ADE-97E0-B0AD580B3355}" dt="2026-02-25T14:04:07.475" v="5811" actId="47"/>
+          <pc:sldLayoutMkLst>
+            <pc:docMk/>
+            <pc:sldMasterMk cId="383322428" sldId="2147483672"/>
+            <pc:sldLayoutMk cId="2804353234" sldId="2147483689"/>
+          </pc:sldLayoutMkLst>
+        </pc:sldLayoutChg>
+        <pc:sldLayoutChg chg="del">
+          <pc:chgData name="faik bilgen" userId="9fcb1696e65a161f" providerId="LiveId" clId="{0C3A4C9E-717D-4ADE-97E0-B0AD580B3355}" dt="2026-02-25T14:04:07.475" v="5811" actId="47"/>
+          <pc:sldLayoutMkLst>
+            <pc:docMk/>
+            <pc:sldMasterMk cId="383322428" sldId="2147483672"/>
+            <pc:sldLayoutMk cId="2620712624" sldId="2147483690"/>
+          </pc:sldLayoutMkLst>
+        </pc:sldLayoutChg>
+        <pc:sldLayoutChg chg="del">
+          <pc:chgData name="faik bilgen" userId="9fcb1696e65a161f" providerId="LiveId" clId="{0C3A4C9E-717D-4ADE-97E0-B0AD580B3355}" dt="2026-02-25T14:04:07.475" v="5811" actId="47"/>
+          <pc:sldLayoutMkLst>
+            <pc:docMk/>
+            <pc:sldMasterMk cId="383322428" sldId="2147483672"/>
+            <pc:sldLayoutMk cId="3155557277" sldId="2147483691"/>
+          </pc:sldLayoutMkLst>
+        </pc:sldLayoutChg>
+        <pc:sldLayoutChg chg="del">
+          <pc:chgData name="faik bilgen" userId="9fcb1696e65a161f" providerId="LiveId" clId="{0C3A4C9E-717D-4ADE-97E0-B0AD580B3355}" dt="2026-02-25T14:04:07.475" v="5811" actId="47"/>
+          <pc:sldLayoutMkLst>
+            <pc:docMk/>
+            <pc:sldMasterMk cId="383322428" sldId="2147483672"/>
+            <pc:sldLayoutMk cId="2103994584" sldId="2147483692"/>
+          </pc:sldLayoutMkLst>
+        </pc:sldLayoutChg>
+        <pc:sldLayoutChg chg="del">
+          <pc:chgData name="faik bilgen" userId="9fcb1696e65a161f" providerId="LiveId" clId="{0C3A4C9E-717D-4ADE-97E0-B0AD580B3355}" dt="2026-02-25T14:04:07.475" v="5811" actId="47"/>
+          <pc:sldLayoutMkLst>
+            <pc:docMk/>
+            <pc:sldMasterMk cId="383322428" sldId="2147483672"/>
+            <pc:sldLayoutMk cId="365747274" sldId="2147483693"/>
+          </pc:sldLayoutMkLst>
+        </pc:sldLayoutChg>
+        <pc:sldLayoutChg chg="del">
+          <pc:chgData name="faik bilgen" userId="9fcb1696e65a161f" providerId="LiveId" clId="{0C3A4C9E-717D-4ADE-97E0-B0AD580B3355}" dt="2026-02-25T14:04:07.475" v="5811" actId="47"/>
+          <pc:sldLayoutMkLst>
+            <pc:docMk/>
+            <pc:sldMasterMk cId="383322428" sldId="2147483672"/>
+            <pc:sldLayoutMk cId="2873886475" sldId="2147483694"/>
+          </pc:sldLayoutMkLst>
+        </pc:sldLayoutChg>
+        <pc:sldLayoutChg chg="del">
+          <pc:chgData name="faik bilgen" userId="9fcb1696e65a161f" providerId="LiveId" clId="{0C3A4C9E-717D-4ADE-97E0-B0AD580B3355}" dt="2026-02-25T14:04:07.475" v="5811" actId="47"/>
+          <pc:sldLayoutMkLst>
+            <pc:docMk/>
+            <pc:sldMasterMk cId="383322428" sldId="2147483672"/>
+            <pc:sldLayoutMk cId="1298423961" sldId="2147483695"/>
+          </pc:sldLayoutMkLst>
+        </pc:sldLayoutChg>
+        <pc:sldLayoutChg chg="del">
+          <pc:chgData name="faik bilgen" userId="9fcb1696e65a161f" providerId="LiveId" clId="{0C3A4C9E-717D-4ADE-97E0-B0AD580B3355}" dt="2026-02-25T14:04:07.475" v="5811" actId="47"/>
+          <pc:sldLayoutMkLst>
+            <pc:docMk/>
+            <pc:sldMasterMk cId="383322428" sldId="2147483672"/>
+            <pc:sldLayoutMk cId="562531699" sldId="2147483696"/>
+          </pc:sldLayoutMkLst>
+        </pc:sldLayoutChg>
+        <pc:sldLayoutChg chg="del">
+          <pc:chgData name="faik bilgen" userId="9fcb1696e65a161f" providerId="LiveId" clId="{0C3A4C9E-717D-4ADE-97E0-B0AD580B3355}" dt="2026-02-25T14:04:07.475" v="5811" actId="47"/>
+          <pc:sldLayoutMkLst>
+            <pc:docMk/>
+            <pc:sldMasterMk cId="383322428" sldId="2147483672"/>
+            <pc:sldLayoutMk cId="3080463896" sldId="2147483697"/>
+          </pc:sldLayoutMkLst>
+        </pc:sldLayoutChg>
+        <pc:sldLayoutChg chg="del">
+          <pc:chgData name="faik bilgen" userId="9fcb1696e65a161f" providerId="LiveId" clId="{0C3A4C9E-717D-4ADE-97E0-B0AD580B3355}" dt="2026-02-25T14:04:07.475" v="5811" actId="47"/>
+          <pc:sldLayoutMkLst>
+            <pc:docMk/>
+            <pc:sldMasterMk cId="383322428" sldId="2147483672"/>
+            <pc:sldLayoutMk cId="2568535119" sldId="2147483698"/>
+          </pc:sldLayoutMkLst>
+        </pc:sldLayoutChg>
+        <pc:sldLayoutChg chg="del">
+          <pc:chgData name="faik bilgen" userId="9fcb1696e65a161f" providerId="LiveId" clId="{0C3A4C9E-717D-4ADE-97E0-B0AD580B3355}" dt="2026-02-25T14:04:07.475" v="5811" actId="47"/>
+          <pc:sldLayoutMkLst>
+            <pc:docMk/>
+            <pc:sldMasterMk cId="383322428" sldId="2147483672"/>
+            <pc:sldLayoutMk cId="2973927861" sldId="2147483699"/>
+          </pc:sldLayoutMkLst>
+        </pc:sldLayoutChg>
+        <pc:sldLayoutChg chg="del">
+          <pc:chgData name="faik bilgen" userId="9fcb1696e65a161f" providerId="LiveId" clId="{0C3A4C9E-717D-4ADE-97E0-B0AD580B3355}" dt="2026-02-25T14:04:07.475" v="5811" actId="47"/>
+          <pc:sldLayoutMkLst>
+            <pc:docMk/>
+            <pc:sldMasterMk cId="383322428" sldId="2147483672"/>
+            <pc:sldLayoutMk cId="3807089031" sldId="2147483700"/>
+          </pc:sldLayoutMkLst>
+        </pc:sldLayoutChg>
+        <pc:sldLayoutChg chg="del">
+          <pc:chgData name="faik bilgen" userId="9fcb1696e65a161f" providerId="LiveId" clId="{0C3A4C9E-717D-4ADE-97E0-B0AD580B3355}" dt="2026-02-25T14:04:07.475" v="5811" actId="47"/>
+          <pc:sldLayoutMkLst>
+            <pc:docMk/>
+            <pc:sldMasterMk cId="383322428" sldId="2147483672"/>
+            <pc:sldLayoutMk cId="3489016089" sldId="2147483701"/>
+          </pc:sldLayoutMkLst>
+        </pc:sldLayoutChg>
+        <pc:sldLayoutChg chg="del">
+          <pc:chgData name="faik bilgen" userId="9fcb1696e65a161f" providerId="LiveId" clId="{0C3A4C9E-717D-4ADE-97E0-B0AD580B3355}" dt="2026-02-25T14:04:07.475" v="5811" actId="47"/>
+          <pc:sldLayoutMkLst>
+            <pc:docMk/>
+            <pc:sldMasterMk cId="383322428" sldId="2147483672"/>
+            <pc:sldLayoutMk cId="980214454" sldId="2147483702"/>
+          </pc:sldLayoutMkLst>
+        </pc:sldLayoutChg>
+        <pc:sldLayoutChg chg="del">
+          <pc:chgData name="faik bilgen" userId="9fcb1696e65a161f" providerId="LiveId" clId="{0C3A4C9E-717D-4ADE-97E0-B0AD580B3355}" dt="2026-02-25T14:04:07.475" v="5811" actId="47"/>
+          <pc:sldLayoutMkLst>
+            <pc:docMk/>
+            <pc:sldMasterMk cId="383322428" sldId="2147483672"/>
+            <pc:sldLayoutMk cId="4109117017" sldId="2147483703"/>
+          </pc:sldLayoutMkLst>
+        </pc:sldLayoutChg>
+        <pc:sldLayoutChg chg="del">
+          <pc:chgData name="faik bilgen" userId="9fcb1696e65a161f" providerId="LiveId" clId="{0C3A4C9E-717D-4ADE-97E0-B0AD580B3355}" dt="2026-02-25T14:04:07.475" v="5811" actId="47"/>
+          <pc:sldLayoutMkLst>
+            <pc:docMk/>
+            <pc:sldMasterMk cId="383322428" sldId="2147483672"/>
+            <pc:sldLayoutMk cId="2482621324" sldId="2147483704"/>
+          </pc:sldLayoutMkLst>
+        </pc:sldLayoutChg>
+        <pc:sldLayoutChg chg="del">
+          <pc:chgData name="faik bilgen" userId="9fcb1696e65a161f" providerId="LiveId" clId="{0C3A4C9E-717D-4ADE-97E0-B0AD580B3355}" dt="2026-02-25T14:04:07.475" v="5811" actId="47"/>
+          <pc:sldLayoutMkLst>
+            <pc:docMk/>
+            <pc:sldMasterMk cId="383322428" sldId="2147483672"/>
+            <pc:sldLayoutMk cId="58191698" sldId="2147483705"/>
+          </pc:sldLayoutMkLst>
+        </pc:sldLayoutChg>
+        <pc:sldLayoutChg chg="del">
+          <pc:chgData name="faik bilgen" userId="9fcb1696e65a161f" providerId="LiveId" clId="{0C3A4C9E-717D-4ADE-97E0-B0AD580B3355}" dt="2026-02-25T14:04:07.475" v="5811" actId="47"/>
+          <pc:sldLayoutMkLst>
+            <pc:docMk/>
+            <pc:sldMasterMk cId="383322428" sldId="2147483672"/>
+            <pc:sldLayoutMk cId="3601638639" sldId="2147483706"/>
+          </pc:sldLayoutMkLst>
+        </pc:sldLayoutChg>
+        <pc:sldLayoutChg chg="del">
+          <pc:chgData name="faik bilgen" userId="9fcb1696e65a161f" providerId="LiveId" clId="{0C3A4C9E-717D-4ADE-97E0-B0AD580B3355}" dt="2026-02-25T14:04:07.475" v="5811" actId="47"/>
+          <pc:sldLayoutMkLst>
+            <pc:docMk/>
+            <pc:sldMasterMk cId="383322428" sldId="2147483672"/>
+            <pc:sldLayoutMk cId="2990809985" sldId="2147483707"/>
+          </pc:sldLayoutMkLst>
+        </pc:sldLayoutChg>
+        <pc:sldLayoutChg chg="del">
+          <pc:chgData name="faik bilgen" userId="9fcb1696e65a161f" providerId="LiveId" clId="{0C3A4C9E-717D-4ADE-97E0-B0AD580B3355}" dt="2026-02-25T14:04:07.475" v="5811" actId="47"/>
+          <pc:sldLayoutMkLst>
+            <pc:docMk/>
+            <pc:sldMasterMk cId="383322428" sldId="2147483672"/>
+            <pc:sldLayoutMk cId="247353233" sldId="2147483708"/>
+          </pc:sldLayoutMkLst>
+        </pc:sldLayoutChg>
+        <pc:sldLayoutChg chg="del">
+          <pc:chgData name="faik bilgen" userId="9fcb1696e65a161f" providerId="LiveId" clId="{0C3A4C9E-717D-4ADE-97E0-B0AD580B3355}" dt="2026-02-25T14:04:07.475" v="5811" actId="47"/>
+          <pc:sldLayoutMkLst>
+            <pc:docMk/>
+            <pc:sldMasterMk cId="383322428" sldId="2147483672"/>
+            <pc:sldLayoutMk cId="2673178539" sldId="2147483709"/>
+          </pc:sldLayoutMkLst>
+        </pc:sldLayoutChg>
+        <pc:sldLayoutChg chg="del">
+          <pc:chgData name="faik bilgen" userId="9fcb1696e65a161f" providerId="LiveId" clId="{0C3A4C9E-717D-4ADE-97E0-B0AD580B3355}" dt="2026-02-25T14:04:07.475" v="5811" actId="47"/>
+          <pc:sldLayoutMkLst>
+            <pc:docMk/>
+            <pc:sldMasterMk cId="383322428" sldId="2147483672"/>
+            <pc:sldLayoutMk cId="250083621" sldId="2147483710"/>
+          </pc:sldLayoutMkLst>
+        </pc:sldLayoutChg>
+        <pc:sldLayoutChg chg="del">
+          <pc:chgData name="faik bilgen" userId="9fcb1696e65a161f" providerId="LiveId" clId="{0C3A4C9E-717D-4ADE-97E0-B0AD580B3355}" dt="2026-02-25T14:04:07.475" v="5811" actId="47"/>
+          <pc:sldLayoutMkLst>
+            <pc:docMk/>
+            <pc:sldMasterMk cId="383322428" sldId="2147483672"/>
+            <pc:sldLayoutMk cId="3950927764" sldId="2147483711"/>
+          </pc:sldLayoutMkLst>
+        </pc:sldLayoutChg>
+        <pc:sldLayoutChg chg="del">
+          <pc:chgData name="faik bilgen" userId="9fcb1696e65a161f" providerId="LiveId" clId="{0C3A4C9E-717D-4ADE-97E0-B0AD580B3355}" dt="2026-02-25T14:04:07.475" v="5811" actId="47"/>
+          <pc:sldLayoutMkLst>
+            <pc:docMk/>
+            <pc:sldMasterMk cId="383322428" sldId="2147483672"/>
+            <pc:sldLayoutMk cId="1148504244" sldId="2147483712"/>
+          </pc:sldLayoutMkLst>
+        </pc:sldLayoutChg>
+        <pc:sldLayoutChg chg="del">
+          <pc:chgData name="faik bilgen" userId="9fcb1696e65a161f" providerId="LiveId" clId="{0C3A4C9E-717D-4ADE-97E0-B0AD580B3355}" dt="2026-02-25T14:04:07.475" v="5811" actId="47"/>
+          <pc:sldLayoutMkLst>
+            <pc:docMk/>
+            <pc:sldMasterMk cId="383322428" sldId="2147483672"/>
+            <pc:sldLayoutMk cId="1979200747" sldId="2147483713"/>
+          </pc:sldLayoutMkLst>
+        </pc:sldLayoutChg>
+        <pc:sldLayoutChg chg="del">
+          <pc:chgData name="faik bilgen" userId="9fcb1696e65a161f" providerId="LiveId" clId="{0C3A4C9E-717D-4ADE-97E0-B0AD580B3355}" dt="2026-02-25T14:04:07.475" v="5811" actId="47"/>
+          <pc:sldLayoutMkLst>
+            <pc:docMk/>
+            <pc:sldMasterMk cId="383322428" sldId="2147483672"/>
+            <pc:sldLayoutMk cId="2451150161" sldId="2147483714"/>
+          </pc:sldLayoutMkLst>
+        </pc:sldLayoutChg>
+        <pc:sldLayoutChg chg="del">
+          <pc:chgData name="faik bilgen" userId="9fcb1696e65a161f" providerId="LiveId" clId="{0C3A4C9E-717D-4ADE-97E0-B0AD580B3355}" dt="2026-02-25T14:04:07.475" v="5811" actId="47"/>
+          <pc:sldLayoutMkLst>
+            <pc:docMk/>
+            <pc:sldMasterMk cId="383322428" sldId="2147483672"/>
+            <pc:sldLayoutMk cId="2934958498" sldId="2147483715"/>
+          </pc:sldLayoutMkLst>
+        </pc:sldLayoutChg>
+        <pc:sldLayoutChg chg="del">
+          <pc:chgData name="faik bilgen" userId="9fcb1696e65a161f" providerId="LiveId" clId="{0C3A4C9E-717D-4ADE-97E0-B0AD580B3355}" dt="2026-02-25T14:04:07.475" v="5811" actId="47"/>
+          <pc:sldLayoutMkLst>
+            <pc:docMk/>
+            <pc:sldMasterMk cId="383322428" sldId="2147483672"/>
+            <pc:sldLayoutMk cId="598070437" sldId="2147483716"/>
+          </pc:sldLayoutMkLst>
+        </pc:sldLayoutChg>
+        <pc:sldLayoutChg chg="del">
+          <pc:chgData name="faik bilgen" userId="9fcb1696e65a161f" providerId="LiveId" clId="{0C3A4C9E-717D-4ADE-97E0-B0AD580B3355}" dt="2026-02-25T14:04:07.475" v="5811" actId="47"/>
+          <pc:sldLayoutMkLst>
+            <pc:docMk/>
+            <pc:sldMasterMk cId="383322428" sldId="2147483672"/>
+            <pc:sldLayoutMk cId="1720895401" sldId="2147483717"/>
+          </pc:sldLayoutMkLst>
+        </pc:sldLayoutChg>
+        <pc:sldLayoutChg chg="del">
+          <pc:chgData name="faik bilgen" userId="9fcb1696e65a161f" providerId="LiveId" clId="{0C3A4C9E-717D-4ADE-97E0-B0AD580B3355}" dt="2026-02-25T14:04:07.475" v="5811" actId="47"/>
+          <pc:sldLayoutMkLst>
+            <pc:docMk/>
+            <pc:sldMasterMk cId="383322428" sldId="2147483672"/>
+            <pc:sldLayoutMk cId="4094069624" sldId="2147483718"/>
+          </pc:sldLayoutMkLst>
+        </pc:sldLayoutChg>
+        <pc:sldLayoutChg chg="del">
+          <pc:chgData name="faik bilgen" userId="9fcb1696e65a161f" providerId="LiveId" clId="{0C3A4C9E-717D-4ADE-97E0-B0AD580B3355}" dt="2026-02-25T14:04:07.475" v="5811" actId="47"/>
+          <pc:sldLayoutMkLst>
+            <pc:docMk/>
+            <pc:sldMasterMk cId="383322428" sldId="2147483672"/>
+            <pc:sldLayoutMk cId="3816113842" sldId="2147483719"/>
+          </pc:sldLayoutMkLst>
+        </pc:sldLayoutChg>
+        <pc:sldLayoutChg chg="del">
+          <pc:chgData name="faik bilgen" userId="9fcb1696e65a161f" providerId="LiveId" clId="{0C3A4C9E-717D-4ADE-97E0-B0AD580B3355}" dt="2026-02-25T14:04:07.475" v="5811" actId="47"/>
+          <pc:sldLayoutMkLst>
+            <pc:docMk/>
+            <pc:sldMasterMk cId="383322428" sldId="2147483672"/>
+            <pc:sldLayoutMk cId="481304415" sldId="2147483720"/>
+          </pc:sldLayoutMkLst>
+        </pc:sldLayoutChg>
+        <pc:sldLayoutChg chg="del">
+          <pc:chgData name="faik bilgen" userId="9fcb1696e65a161f" providerId="LiveId" clId="{0C3A4C9E-717D-4ADE-97E0-B0AD580B3355}" dt="2026-02-25T14:04:07.475" v="5811" actId="47"/>
+          <pc:sldLayoutMkLst>
+            <pc:docMk/>
+            <pc:sldMasterMk cId="383322428" sldId="2147483672"/>
+            <pc:sldLayoutMk cId="978399900" sldId="2147483721"/>
+          </pc:sldLayoutMkLst>
+        </pc:sldLayoutChg>
+        <pc:sldLayoutChg chg="del">
+          <pc:chgData name="faik bilgen" userId="9fcb1696e65a161f" providerId="LiveId" clId="{0C3A4C9E-717D-4ADE-97E0-B0AD580B3355}" dt="2026-02-25T14:04:07.475" v="5811" actId="47"/>
+          <pc:sldLayoutMkLst>
+            <pc:docMk/>
+            <pc:sldMasterMk cId="383322428" sldId="2147483672"/>
+            <pc:sldLayoutMk cId="2218991397" sldId="2147483722"/>
+          </pc:sldLayoutMkLst>
+        </pc:sldLayoutChg>
+        <pc:sldLayoutChg chg="del">
+          <pc:chgData name="faik bilgen" userId="9fcb1696e65a161f" providerId="LiveId" clId="{0C3A4C9E-717D-4ADE-97E0-B0AD580B3355}" dt="2026-02-25T14:04:07.475" v="5811" actId="47"/>
+          <pc:sldLayoutMkLst>
+            <pc:docMk/>
+            <pc:sldMasterMk cId="383322428" sldId="2147483672"/>
+            <pc:sldLayoutMk cId="2933359065" sldId="2147483723"/>
+          </pc:sldLayoutMkLst>
+        </pc:sldLayoutChg>
+        <pc:sldLayoutChg chg="del">
+          <pc:chgData name="faik bilgen" userId="9fcb1696e65a161f" providerId="LiveId" clId="{0C3A4C9E-717D-4ADE-97E0-B0AD580B3355}" dt="2026-02-25T14:04:07.475" v="5811" actId="47"/>
+          <pc:sldLayoutMkLst>
+            <pc:docMk/>
+            <pc:sldMasterMk cId="383322428" sldId="2147483672"/>
+            <pc:sldLayoutMk cId="3577606658" sldId="2147483724"/>
+          </pc:sldLayoutMkLst>
+        </pc:sldLayoutChg>
+        <pc:sldLayoutChg chg="del">
+          <pc:chgData name="faik bilgen" userId="9fcb1696e65a161f" providerId="LiveId" clId="{0C3A4C9E-717D-4ADE-97E0-B0AD580B3355}" dt="2026-02-25T14:04:07.475" v="5811" actId="47"/>
+          <pc:sldLayoutMkLst>
+            <pc:docMk/>
+            <pc:sldMasterMk cId="383322428" sldId="2147483672"/>
+            <pc:sldLayoutMk cId="1639699848" sldId="2147483725"/>
+          </pc:sldLayoutMkLst>
+        </pc:sldLayoutChg>
+        <pc:sldLayoutChg chg="del">
+          <pc:chgData name="faik bilgen" userId="9fcb1696e65a161f" providerId="LiveId" clId="{0C3A4C9E-717D-4ADE-97E0-B0AD580B3355}" dt="2026-02-25T14:04:07.475" v="5811" actId="47"/>
+          <pc:sldLayoutMkLst>
+            <pc:docMk/>
+            <pc:sldMasterMk cId="383322428" sldId="2147483672"/>
+            <pc:sldLayoutMk cId="1985154233" sldId="2147483726"/>
+          </pc:sldLayoutMkLst>
+        </pc:sldLayoutChg>
+        <pc:sldLayoutChg chg="del">
+          <pc:chgData name="faik bilgen" userId="9fcb1696e65a161f" providerId="LiveId" clId="{0C3A4C9E-717D-4ADE-97E0-B0AD580B3355}" dt="2026-02-25T14:04:07.475" v="5811" actId="47"/>
+          <pc:sldLayoutMkLst>
+            <pc:docMk/>
+            <pc:sldMasterMk cId="383322428" sldId="2147483672"/>
+            <pc:sldLayoutMk cId="4164940663" sldId="2147483727"/>
+          </pc:sldLayoutMkLst>
+        </pc:sldLayoutChg>
+        <pc:sldLayoutChg chg="del">
+          <pc:chgData name="faik bilgen" userId="9fcb1696e65a161f" providerId="LiveId" clId="{0C3A4C9E-717D-4ADE-97E0-B0AD580B3355}" dt="2026-02-25T14:04:07.475" v="5811" actId="47"/>
+          <pc:sldLayoutMkLst>
+            <pc:docMk/>
+            <pc:sldMasterMk cId="383322428" sldId="2147483672"/>
+            <pc:sldLayoutMk cId="2915503568" sldId="2147483728"/>
+          </pc:sldLayoutMkLst>
+        </pc:sldLayoutChg>
+        <pc:sldLayoutChg chg="del">
+          <pc:chgData name="faik bilgen" userId="9fcb1696e65a161f" providerId="LiveId" clId="{0C3A4C9E-717D-4ADE-97E0-B0AD580B3355}" dt="2026-02-25T14:04:07.475" v="5811" actId="47"/>
+          <pc:sldLayoutMkLst>
+            <pc:docMk/>
+            <pc:sldMasterMk cId="383322428" sldId="2147483672"/>
+            <pc:sldLayoutMk cId="49491502" sldId="2147483729"/>
+          </pc:sldLayoutMkLst>
+        </pc:sldLayoutChg>
+        <pc:sldLayoutChg chg="del">
+          <pc:chgData name="faik bilgen" userId="9fcb1696e65a161f" providerId="LiveId" clId="{0C3A4C9E-717D-4ADE-97E0-B0AD580B3355}" dt="2026-02-25T14:04:07.475" v="5811" actId="47"/>
+          <pc:sldLayoutMkLst>
+            <pc:docMk/>
+            <pc:sldMasterMk cId="383322428" sldId="2147483672"/>
+            <pc:sldLayoutMk cId="3990594326" sldId="2147483730"/>
+          </pc:sldLayoutMkLst>
+        </pc:sldLayoutChg>
+        <pc:sldLayoutChg chg="del">
+          <pc:chgData name="faik bilgen" userId="9fcb1696e65a161f" providerId="LiveId" clId="{0C3A4C9E-717D-4ADE-97E0-B0AD580B3355}" dt="2026-02-25T14:04:07.475" v="5811" actId="47"/>
+          <pc:sldLayoutMkLst>
+            <pc:docMk/>
+            <pc:sldMasterMk cId="383322428" sldId="2147483672"/>
+            <pc:sldLayoutMk cId="3955620807" sldId="2147483731"/>
+          </pc:sldLayoutMkLst>
+        </pc:sldLayoutChg>
+        <pc:sldLayoutChg chg="del">
+          <pc:chgData name="faik bilgen" userId="9fcb1696e65a161f" providerId="LiveId" clId="{0C3A4C9E-717D-4ADE-97E0-B0AD580B3355}" dt="2026-02-25T14:04:07.475" v="5811" actId="47"/>
+          <pc:sldLayoutMkLst>
+            <pc:docMk/>
+            <pc:sldMasterMk cId="383322428" sldId="2147483672"/>
+            <pc:sldLayoutMk cId="980067283" sldId="2147483732"/>
+          </pc:sldLayoutMkLst>
+        </pc:sldLayoutChg>
+        <pc:sldLayoutChg chg="del">
+          <pc:chgData name="faik bilgen" userId="9fcb1696e65a161f" providerId="LiveId" clId="{0C3A4C9E-717D-4ADE-97E0-B0AD580B3355}" dt="2026-02-25T14:04:07.475" v="5811" actId="47"/>
+          <pc:sldLayoutMkLst>
+            <pc:docMk/>
+            <pc:sldMasterMk cId="383322428" sldId="2147483672"/>
+            <pc:sldLayoutMk cId="979078848" sldId="2147483733"/>
+          </pc:sldLayoutMkLst>
+        </pc:sldLayoutChg>
+        <pc:sldLayoutChg chg="del">
+          <pc:chgData name="faik bilgen" userId="9fcb1696e65a161f" providerId="LiveId" clId="{0C3A4C9E-717D-4ADE-97E0-B0AD580B3355}" dt="2026-02-25T14:04:07.475" v="5811" actId="47"/>
+          <pc:sldLayoutMkLst>
+            <pc:docMk/>
+            <pc:sldMasterMk cId="383322428" sldId="2147483672"/>
+            <pc:sldLayoutMk cId="747904086" sldId="2147483734"/>
+          </pc:sldLayoutMkLst>
+        </pc:sldLayoutChg>
+        <pc:sldLayoutChg chg="del">
+          <pc:chgData name="faik bilgen" userId="9fcb1696e65a161f" providerId="LiveId" clId="{0C3A4C9E-717D-4ADE-97E0-B0AD580B3355}" dt="2026-02-25T14:04:07.475" v="5811" actId="47"/>
+          <pc:sldLayoutMkLst>
+            <pc:docMk/>
+            <pc:sldMasterMk cId="383322428" sldId="2147483672"/>
+            <pc:sldLayoutMk cId="82905779" sldId="2147483735"/>
+          </pc:sldLayoutMkLst>
+        </pc:sldLayoutChg>
+        <pc:sldLayoutChg chg="del">
+          <pc:chgData name="faik bilgen" userId="9fcb1696e65a161f" providerId="LiveId" clId="{0C3A4C9E-717D-4ADE-97E0-B0AD580B3355}" dt="2026-02-25T14:04:07.475" v="5811" actId="47"/>
+          <pc:sldLayoutMkLst>
+            <pc:docMk/>
+            <pc:sldMasterMk cId="383322428" sldId="2147483672"/>
+            <pc:sldLayoutMk cId="3477708863" sldId="2147483736"/>
+          </pc:sldLayoutMkLst>
+        </pc:sldLayoutChg>
+        <pc:sldLayoutChg chg="del">
+          <pc:chgData name="faik bilgen" userId="9fcb1696e65a161f" providerId="LiveId" clId="{0C3A4C9E-717D-4ADE-97E0-B0AD580B3355}" dt="2026-02-25T14:04:07.475" v="5811" actId="47"/>
+          <pc:sldLayoutMkLst>
+            <pc:docMk/>
+            <pc:sldMasterMk cId="383322428" sldId="2147483672"/>
+            <pc:sldLayoutMk cId="3602381604" sldId="2147483737"/>
+          </pc:sldLayoutMkLst>
+        </pc:sldLayoutChg>
+        <pc:sldLayoutChg chg="del">
+          <pc:chgData name="faik bilgen" userId="9fcb1696e65a161f" providerId="LiveId" clId="{0C3A4C9E-717D-4ADE-97E0-B0AD580B3355}" dt="2026-02-25T14:04:07.475" v="5811" actId="47"/>
+          <pc:sldLayoutMkLst>
+            <pc:docMk/>
+            <pc:sldMasterMk cId="383322428" sldId="2147483672"/>
+            <pc:sldLayoutMk cId="2689350475" sldId="2147483738"/>
+          </pc:sldLayoutMkLst>
+        </pc:sldLayoutChg>
+        <pc:sldLayoutChg chg="del">
+          <pc:chgData name="faik bilgen" userId="9fcb1696e65a161f" providerId="LiveId" clId="{0C3A4C9E-717D-4ADE-97E0-B0AD580B3355}" dt="2026-02-25T14:04:07.475" v="5811" actId="47"/>
+          <pc:sldLayoutMkLst>
+            <pc:docMk/>
+            <pc:sldMasterMk cId="383322428" sldId="2147483672"/>
+            <pc:sldLayoutMk cId="387003613" sldId="2147483739"/>
+          </pc:sldLayoutMkLst>
+        </pc:sldLayoutChg>
+        <pc:sldLayoutChg chg="del">
+          <pc:chgData name="faik bilgen" userId="9fcb1696e65a161f" providerId="LiveId" clId="{0C3A4C9E-717D-4ADE-97E0-B0AD580B3355}" dt="2026-02-25T14:04:07.475" v="5811" actId="47"/>
+          <pc:sldLayoutMkLst>
+            <pc:docMk/>
+            <pc:sldMasterMk cId="383322428" sldId="2147483672"/>
+            <pc:sldLayoutMk cId="2046232314" sldId="2147483740"/>
+          </pc:sldLayoutMkLst>
+        </pc:sldLayoutChg>
+        <pc:sldLayoutChg chg="del">
+          <pc:chgData name="faik bilgen" userId="9fcb1696e65a161f" providerId="LiveId" clId="{0C3A4C9E-717D-4ADE-97E0-B0AD580B3355}" dt="2026-02-25T14:04:07.475" v="5811" actId="47"/>
+          <pc:sldLayoutMkLst>
+            <pc:docMk/>
+            <pc:sldMasterMk cId="383322428" sldId="2147483672"/>
+            <pc:sldLayoutMk cId="1995880023" sldId="2147483741"/>
+          </pc:sldLayoutMkLst>
+        </pc:sldLayoutChg>
+        <pc:sldLayoutChg chg="del">
+          <pc:chgData name="faik bilgen" userId="9fcb1696e65a161f" providerId="LiveId" clId="{0C3A4C9E-717D-4ADE-97E0-B0AD580B3355}" dt="2026-02-25T14:04:07.475" v="5811" actId="47"/>
+          <pc:sldLayoutMkLst>
+            <pc:docMk/>
+            <pc:sldMasterMk cId="383322428" sldId="2147483672"/>
+            <pc:sldLayoutMk cId="3636176860" sldId="2147483742"/>
+          </pc:sldLayoutMkLst>
+        </pc:sldLayoutChg>
+        <pc:sldLayoutChg chg="del">
+          <pc:chgData name="faik bilgen" userId="9fcb1696e65a161f" providerId="LiveId" clId="{0C3A4C9E-717D-4ADE-97E0-B0AD580B3355}" dt="2026-02-25T14:04:07.475" v="5811" actId="47"/>
+          <pc:sldLayoutMkLst>
+            <pc:docMk/>
+            <pc:sldMasterMk cId="383322428" sldId="2147483672"/>
+            <pc:sldLayoutMk cId="420049415" sldId="2147483743"/>
+          </pc:sldLayoutMkLst>
+        </pc:sldLayoutChg>
+        <pc:sldLayoutChg chg="del">
+          <pc:chgData name="faik bilgen" userId="9fcb1696e65a161f" providerId="LiveId" clId="{0C3A4C9E-717D-4ADE-97E0-B0AD580B3355}" dt="2026-02-25T14:04:07.475" v="5811" actId="47"/>
+          <pc:sldLayoutMkLst>
+            <pc:docMk/>
+            <pc:sldMasterMk cId="383322428" sldId="2147483672"/>
+            <pc:sldLayoutMk cId="1749222678" sldId="2147483744"/>
+          </pc:sldLayoutMkLst>
+        </pc:sldLayoutChg>
+        <pc:sldLayoutChg chg="del">
+          <pc:chgData name="faik bilgen" userId="9fcb1696e65a161f" providerId="LiveId" clId="{0C3A4C9E-717D-4ADE-97E0-B0AD580B3355}" dt="2026-02-25T14:04:07.475" v="5811" actId="47"/>
+          <pc:sldLayoutMkLst>
+            <pc:docMk/>
+            <pc:sldMasterMk cId="383322428" sldId="2147483672"/>
+            <pc:sldLayoutMk cId="949250296" sldId="2147483745"/>
+          </pc:sldLayoutMkLst>
+        </pc:sldLayoutChg>
+        <pc:sldLayoutChg chg="del">
+          <pc:chgData name="faik bilgen" userId="9fcb1696e65a161f" providerId="LiveId" clId="{0C3A4C9E-717D-4ADE-97E0-B0AD580B3355}" dt="2026-02-25T14:04:07.475" v="5811" actId="47"/>
+          <pc:sldLayoutMkLst>
+            <pc:docMk/>
+            <pc:sldMasterMk cId="383322428" sldId="2147483672"/>
+            <pc:sldLayoutMk cId="2340082694" sldId="2147483746"/>
+          </pc:sldLayoutMkLst>
+        </pc:sldLayoutChg>
+        <pc:sldLayoutChg chg="del">
+          <pc:chgData name="faik bilgen" userId="9fcb1696e65a161f" providerId="LiveId" clId="{0C3A4C9E-717D-4ADE-97E0-B0AD580B3355}" dt="2026-02-25T14:04:07.475" v="5811" actId="47"/>
+          <pc:sldLayoutMkLst>
+            <pc:docMk/>
+            <pc:sldMasterMk cId="383322428" sldId="2147483672"/>
+            <pc:sldLayoutMk cId="240339034" sldId="2147483747"/>
+          </pc:sldLayoutMkLst>
+        </pc:sldLayoutChg>
+        <pc:sldLayoutChg chg="del">
+          <pc:chgData name="faik bilgen" userId="9fcb1696e65a161f" providerId="LiveId" clId="{0C3A4C9E-717D-4ADE-97E0-B0AD580B3355}" dt="2026-02-25T14:04:07.475" v="5811" actId="47"/>
+          <pc:sldLayoutMkLst>
+            <pc:docMk/>
+            <pc:sldMasterMk cId="383322428" sldId="2147483672"/>
+            <pc:sldLayoutMk cId="465386768" sldId="2147483748"/>
+          </pc:sldLayoutMkLst>
+        </pc:sldLayoutChg>
+        <pc:sldLayoutChg chg="del">
+          <pc:chgData name="faik bilgen" userId="9fcb1696e65a161f" providerId="LiveId" clId="{0C3A4C9E-717D-4ADE-97E0-B0AD580B3355}" dt="2026-02-25T14:04:07.475" v="5811" actId="47"/>
+          <pc:sldLayoutMkLst>
+            <pc:docMk/>
+            <pc:sldMasterMk cId="383322428" sldId="2147483672"/>
+            <pc:sldLayoutMk cId="3308657726" sldId="2147483749"/>
+          </pc:sldLayoutMkLst>
+        </pc:sldLayoutChg>
+        <pc:sldLayoutChg chg="del">
+          <pc:chgData name="faik bilgen" userId="9fcb1696e65a161f" providerId="LiveId" clId="{0C3A4C9E-717D-4ADE-97E0-B0AD580B3355}" dt="2026-02-25T14:04:07.475" v="5811" actId="47"/>
+          <pc:sldLayoutMkLst>
+            <pc:docMk/>
+            <pc:sldMasterMk cId="383322428" sldId="2147483672"/>
+            <pc:sldLayoutMk cId="2228840293" sldId="2147483750"/>
+          </pc:sldLayoutMkLst>
+        </pc:sldLayoutChg>
+        <pc:sldLayoutChg chg="del">
+          <pc:chgData name="faik bilgen" userId="9fcb1696e65a161f" providerId="LiveId" clId="{0C3A4C9E-717D-4ADE-97E0-B0AD580B3355}" dt="2026-02-25T14:04:07.475" v="5811" actId="47"/>
+          <pc:sldLayoutMkLst>
+            <pc:docMk/>
+            <pc:sldMasterMk cId="383322428" sldId="2147483672"/>
+            <pc:sldLayoutMk cId="4027556814" sldId="2147483751"/>
+          </pc:sldLayoutMkLst>
+        </pc:sldLayoutChg>
+        <pc:sldLayoutChg chg="del">
+          <pc:chgData name="faik bilgen" userId="9fcb1696e65a161f" providerId="LiveId" clId="{0C3A4C9E-717D-4ADE-97E0-B0AD580B3355}" dt="2026-02-25T14:04:07.475" v="5811" actId="47"/>
+          <pc:sldLayoutMkLst>
+            <pc:docMk/>
+            <pc:sldMasterMk cId="383322428" sldId="2147483672"/>
+            <pc:sldLayoutMk cId="378024358" sldId="2147483752"/>
+          </pc:sldLayoutMkLst>
+        </pc:sldLayoutChg>
+        <pc:sldLayoutChg chg="del">
+          <pc:chgData name="faik bilgen" userId="9fcb1696e65a161f" providerId="LiveId" clId="{0C3A4C9E-717D-4ADE-97E0-B0AD580B3355}" dt="2026-02-25T14:04:07.475" v="5811" actId="47"/>
+          <pc:sldLayoutMkLst>
+            <pc:docMk/>
+            <pc:sldMasterMk cId="383322428" sldId="2147483672"/>
+            <pc:sldLayoutMk cId="666527244" sldId="2147483753"/>
+          </pc:sldLayoutMkLst>
+        </pc:sldLayoutChg>
+        <pc:sldLayoutChg chg="del">
+          <pc:chgData name="faik bilgen" userId="9fcb1696e65a161f" providerId="LiveId" clId="{0C3A4C9E-717D-4ADE-97E0-B0AD580B3355}" dt="2026-02-25T14:04:07.475" v="5811" actId="47"/>
+          <pc:sldLayoutMkLst>
+            <pc:docMk/>
+            <pc:sldMasterMk cId="383322428" sldId="2147483672"/>
+            <pc:sldLayoutMk cId="393835523" sldId="2147483754"/>
+          </pc:sldLayoutMkLst>
+        </pc:sldLayoutChg>
+        <pc:sldLayoutChg chg="del">
+          <pc:chgData name="faik bilgen" userId="9fcb1696e65a161f" providerId="LiveId" clId="{0C3A4C9E-717D-4ADE-97E0-B0AD580B3355}" dt="2026-02-25T14:04:07.475" v="5811" actId="47"/>
+          <pc:sldLayoutMkLst>
+            <pc:docMk/>
+            <pc:sldMasterMk cId="383322428" sldId="2147483672"/>
+            <pc:sldLayoutMk cId="2959103667" sldId="2147483755"/>
+          </pc:sldLayoutMkLst>
+        </pc:sldLayoutChg>
+        <pc:sldLayoutChg chg="del">
+          <pc:chgData name="faik bilgen" userId="9fcb1696e65a161f" providerId="LiveId" clId="{0C3A4C9E-717D-4ADE-97E0-B0AD580B3355}" dt="2026-02-25T14:04:07.475" v="5811" actId="47"/>
+          <pc:sldLayoutMkLst>
+            <pc:docMk/>
+            <pc:sldMasterMk cId="383322428" sldId="2147483672"/>
+            <pc:sldLayoutMk cId="4117229313" sldId="2147483756"/>
+          </pc:sldLayoutMkLst>
+        </pc:sldLayoutChg>
+        <pc:sldLayoutChg chg="del">
+          <pc:chgData name="faik bilgen" userId="9fcb1696e65a161f" providerId="LiveId" clId="{0C3A4C9E-717D-4ADE-97E0-B0AD580B3355}" dt="2026-02-25T14:04:07.475" v="5811" actId="47"/>
+          <pc:sldLayoutMkLst>
+            <pc:docMk/>
+            <pc:sldMasterMk cId="383322428" sldId="2147483672"/>
+            <pc:sldLayoutMk cId="1740212437" sldId="2147483757"/>
+          </pc:sldLayoutMkLst>
+        </pc:sldLayoutChg>
+      </pc:sldMasterChg>
     </pc:docChg>
   </pc:docChgLst>
 </pc:chgInfo>
@@ -451,7 +1002,7 @@
           <a:p>
             <a:fld id="{0385D07E-B132-4C8F-A144-2D501431D798}" type="datetimeFigureOut">
               <a:rPr lang="en-US" smtClean="0"/>
-              <a:t>2/5/2026</a:t>
+              <a:t>2/25/2026</a:t>
             </a:fld>
             <a:endParaRPr lang="en-US"/>
           </a:p>
@@ -1054,7 +1605,7 @@
           <a:p>
             <a:fld id="{B9268321-C9E7-441E-8ECB-F5B48CA38B30}" type="datetimeFigureOut">
               <a:rPr lang="en-US" smtClean="0"/>
-              <a:t>2/5/2026</a:t>
+              <a:t>2/25/2026</a:t>
             </a:fld>
             <a:endParaRPr lang="en-US"/>
           </a:p>
@@ -1252,7 +1803,7 @@
           <a:p>
             <a:fld id="{B9268321-C9E7-441E-8ECB-F5B48CA38B30}" type="datetimeFigureOut">
               <a:rPr lang="en-US" smtClean="0"/>
-              <a:t>2/5/2026</a:t>
+              <a:t>2/25/2026</a:t>
             </a:fld>
             <a:endParaRPr lang="en-US"/>
           </a:p>
@@ -1460,7 +2011,7 @@
           <a:p>
             <a:fld id="{B9268321-C9E7-441E-8ECB-F5B48CA38B30}" type="datetimeFigureOut">
               <a:rPr lang="en-US" smtClean="0"/>
-              <a:t>2/5/2026</a:t>
+              <a:t>2/25/2026</a:t>
             </a:fld>
             <a:endParaRPr lang="en-US"/>
           </a:p>
@@ -1658,7 +2209,7 @@
           <a:p>
             <a:fld id="{B9268321-C9E7-441E-8ECB-F5B48CA38B30}" type="datetimeFigureOut">
               <a:rPr lang="en-US" smtClean="0"/>
-              <a:t>2/5/2026</a:t>
+              <a:t>2/25/2026</a:t>
             </a:fld>
             <a:endParaRPr lang="en-US"/>
           </a:p>
@@ -1933,7 +2484,7 @@
           <a:p>
             <a:fld id="{B9268321-C9E7-441E-8ECB-F5B48CA38B30}" type="datetimeFigureOut">
               <a:rPr lang="en-US" smtClean="0"/>
-              <a:t>2/5/2026</a:t>
+              <a:t>2/25/2026</a:t>
             </a:fld>
             <a:endParaRPr lang="en-US"/>
           </a:p>
@@ -2198,7 +2749,7 @@
           <a:p>
             <a:fld id="{B9268321-C9E7-441E-8ECB-F5B48CA38B30}" type="datetimeFigureOut">
               <a:rPr lang="en-US" smtClean="0"/>
-              <a:t>2/5/2026</a:t>
+              <a:t>2/25/2026</a:t>
             </a:fld>
             <a:endParaRPr lang="en-US"/>
           </a:p>
@@ -2610,7 +3161,7 @@
           <a:p>
             <a:fld id="{B9268321-C9E7-441E-8ECB-F5B48CA38B30}" type="datetimeFigureOut">
               <a:rPr lang="en-US" smtClean="0"/>
-              <a:t>2/5/2026</a:t>
+              <a:t>2/25/2026</a:t>
             </a:fld>
             <a:endParaRPr lang="en-US"/>
           </a:p>
@@ -2751,7 +3302,7 @@
           <a:p>
             <a:fld id="{B9268321-C9E7-441E-8ECB-F5B48CA38B30}" type="datetimeFigureOut">
               <a:rPr lang="en-US" smtClean="0"/>
-              <a:t>2/5/2026</a:t>
+              <a:t>2/25/2026</a:t>
             </a:fld>
             <a:endParaRPr lang="en-US"/>
           </a:p>
@@ -2864,7 +3415,7 @@
           <a:p>
             <a:fld id="{B9268321-C9E7-441E-8ECB-F5B48CA38B30}" type="datetimeFigureOut">
               <a:rPr lang="en-US" smtClean="0"/>
-              <a:t>2/5/2026</a:t>
+              <a:t>2/25/2026</a:t>
             </a:fld>
             <a:endParaRPr lang="en-US"/>
           </a:p>
@@ -3175,7 +3726,7 @@
           <a:p>
             <a:fld id="{B9268321-C9E7-441E-8ECB-F5B48CA38B30}" type="datetimeFigureOut">
               <a:rPr lang="en-US" smtClean="0"/>
-              <a:t>2/5/2026</a:t>
+              <a:t>2/25/2026</a:t>
             </a:fld>
             <a:endParaRPr lang="en-US"/>
           </a:p>
@@ -3463,7 +4014,7 @@
           <a:p>
             <a:fld id="{B9268321-C9E7-441E-8ECB-F5B48CA38B30}" type="datetimeFigureOut">
               <a:rPr lang="en-US" smtClean="0"/>
-              <a:t>2/5/2026</a:t>
+              <a:t>2/25/2026</a:t>
             </a:fld>
             <a:endParaRPr lang="en-US"/>
           </a:p>
@@ -3704,7 +4255,7 @@
           <a:p>
             <a:fld id="{B9268321-C9E7-441E-8ECB-F5B48CA38B30}" type="datetimeFigureOut">
               <a:rPr lang="en-US" smtClean="0"/>
-              <a:t>2/5/2026</a:t>
+              <a:t>2/25/2026</a:t>
             </a:fld>
             <a:endParaRPr lang="en-US"/>
           </a:p>
@@ -4196,6 +4747,272 @@
 </p:sld>
 </file>
 
+<file path=ppt/slides/slide10.xml><?xml version="1.0" encoding="utf-8"?>
+<p:sld xmlns:a="http://schemas.openxmlformats.org/drawingml/2006/main" xmlns:r="http://schemas.openxmlformats.org/officeDocument/2006/relationships" xmlns:p="http://schemas.openxmlformats.org/presentationml/2006/main">
+  <p:cSld>
+    <p:bg>
+      <p:bgPr>
+        <a:solidFill>
+          <a:schemeClr val="bg1"/>
+        </a:solidFill>
+        <a:effectLst/>
+      </p:bgPr>
+    </p:bg>
+    <p:spTree>
+      <p:nvGrpSpPr>
+        <p:cNvPr id="1" name="">
+          <a:extLst>
+            <a:ext uri="{FF2B5EF4-FFF2-40B4-BE49-F238E27FC236}">
+              <a16:creationId xmlns:a16="http://schemas.microsoft.com/office/drawing/2014/main" id="{4A8299C4-A57F-F76F-A252-0BDFCC66E676}"/>
+            </a:ext>
+          </a:extLst>
+        </p:cNvPr>
+        <p:cNvGrpSpPr/>
+        <p:nvPr/>
+      </p:nvGrpSpPr>
+      <p:grpSpPr>
+        <a:xfrm>
+          <a:off x="0" y="0"/>
+          <a:ext cx="0" cy="0"/>
+          <a:chOff x="0" y="0"/>
+          <a:chExt cx="0" cy="0"/>
+        </a:xfrm>
+      </p:grpSpPr>
+      <p:sp useBgFill="1">
+        <p:nvSpPr>
+          <p:cNvPr id="24" name="Rectangle 23">
+            <a:extLst>
+              <a:ext uri="{FF2B5EF4-FFF2-40B4-BE49-F238E27FC236}">
+                <a16:creationId xmlns:a16="http://schemas.microsoft.com/office/drawing/2014/main" id="{D79EAD09-A52B-3F40-20A0-992FD5B02C2D}"/>
+              </a:ext>
+              <a:ext uri="{C183D7F6-B498-43B3-948B-1728B52AA6E4}">
+                <adec:decorative xmlns:adec="http://schemas.microsoft.com/office/drawing/2017/decorative" val="1"/>
+              </a:ext>
+            </a:extLst>
+          </p:cNvPr>
+          <p:cNvSpPr>
+            <a:spLocks noGrp="1" noRot="1" noChangeAspect="1" noMove="1" noResize="1" noEditPoints="1" noAdjustHandles="1" noChangeArrowheads="1" noChangeShapeType="1" noTextEdit="1"/>
+          </p:cNvSpPr>
+          <p:nvPr>
+            <p:extLst>
+              <p:ext uri="{386F3935-93C4-4BCD-93E2-E3B085C9AB24}">
+                <p16:designElem xmlns:p16="http://schemas.microsoft.com/office/powerpoint/2015/main" val="1"/>
+              </p:ext>
+            </p:extLst>
+          </p:nvPr>
+        </p:nvSpPr>
+        <p:spPr>
+          <a:xfrm>
+            <a:off x="3048" y="4293"/>
+            <a:ext cx="12188952" cy="6858000"/>
+          </a:xfrm>
+          <a:prstGeom prst="rect">
+            <a:avLst/>
+          </a:prstGeom>
+          <a:ln>
+            <a:noFill/>
+          </a:ln>
+        </p:spPr>
+        <p:style>
+          <a:lnRef idx="2">
+            <a:schemeClr val="accent1">
+              <a:shade val="50000"/>
+            </a:schemeClr>
+          </a:lnRef>
+          <a:fillRef idx="1">
+            <a:schemeClr val="accent1"/>
+          </a:fillRef>
+          <a:effectRef idx="0">
+            <a:schemeClr val="accent1"/>
+          </a:effectRef>
+          <a:fontRef idx="minor">
+            <a:schemeClr val="lt1"/>
+          </a:fontRef>
+        </p:style>
+        <p:txBody>
+          <a:bodyPr rtlCol="0" anchor="ctr"/>
+          <a:lstStyle/>
+          <a:p>
+            <a:pPr algn="ctr"/>
+            <a:endParaRPr lang="en-US"/>
+          </a:p>
+        </p:txBody>
+      </p:sp>
+      <p:sp>
+        <p:nvSpPr>
+          <p:cNvPr id="25" name="Rectangle 24">
+            <a:extLst>
+              <a:ext uri="{FF2B5EF4-FFF2-40B4-BE49-F238E27FC236}">
+                <a16:creationId xmlns:a16="http://schemas.microsoft.com/office/drawing/2014/main" id="{E3C6766D-7230-6D6A-2178-AFEA6D3E8834}"/>
+              </a:ext>
+              <a:ext uri="{C183D7F6-B498-43B3-948B-1728B52AA6E4}">
+                <adec:decorative xmlns:adec="http://schemas.microsoft.com/office/drawing/2017/decorative" val="1"/>
+              </a:ext>
+            </a:extLst>
+          </p:cNvPr>
+          <p:cNvSpPr>
+            <a:spLocks noGrp="1" noRot="1" noChangeAspect="1" noMove="1" noResize="1" noEditPoints="1" noAdjustHandles="1" noChangeArrowheads="1" noChangeShapeType="1" noTextEdit="1"/>
+          </p:cNvSpPr>
+          <p:nvPr>
+            <p:extLst>
+              <p:ext uri="{386F3935-93C4-4BCD-93E2-E3B085C9AB24}">
+                <p16:designElem xmlns:p16="http://schemas.microsoft.com/office/powerpoint/2015/main" val="1"/>
+              </p:ext>
+            </p:extLst>
+          </p:nvPr>
+        </p:nvSpPr>
+        <p:spPr>
+          <a:xfrm>
+            <a:off x="0" y="-4"/>
+            <a:ext cx="4167268" cy="6858004"/>
+          </a:xfrm>
+          <a:prstGeom prst="rect">
+            <a:avLst/>
+          </a:prstGeom>
+          <a:solidFill>
+            <a:schemeClr val="accent2"/>
+          </a:solidFill>
+          <a:ln>
+            <a:noFill/>
+          </a:ln>
+        </p:spPr>
+        <p:style>
+          <a:lnRef idx="2">
+            <a:schemeClr val="accent1">
+              <a:shade val="50000"/>
+            </a:schemeClr>
+          </a:lnRef>
+          <a:fillRef idx="1">
+            <a:schemeClr val="accent1"/>
+          </a:fillRef>
+          <a:effectRef idx="0">
+            <a:schemeClr val="accent1"/>
+          </a:effectRef>
+          <a:fontRef idx="minor">
+            <a:schemeClr val="lt1"/>
+          </a:fontRef>
+        </p:style>
+        <p:txBody>
+          <a:bodyPr rtlCol="0" anchor="ctr"/>
+          <a:lstStyle/>
+          <a:p>
+            <a:pPr algn="ctr"/>
+            <a:endParaRPr lang="en-US"/>
+          </a:p>
+        </p:txBody>
+      </p:sp>
+      <p:sp>
+        <p:nvSpPr>
+          <p:cNvPr id="26" name="Arc 25">
+            <a:extLst>
+              <a:ext uri="{FF2B5EF4-FFF2-40B4-BE49-F238E27FC236}">
+                <a16:creationId xmlns:a16="http://schemas.microsoft.com/office/drawing/2014/main" id="{7098CF42-3639-BD0B-AB92-5E94C9F7FB6D}"/>
+              </a:ext>
+              <a:ext uri="{C183D7F6-B498-43B3-948B-1728B52AA6E4}">
+                <adec:decorative xmlns:adec="http://schemas.microsoft.com/office/drawing/2017/decorative" val="1"/>
+              </a:ext>
+            </a:extLst>
+          </p:cNvPr>
+          <p:cNvSpPr>
+            <a:spLocks noGrp="1" noRot="1" noChangeAspect="1" noMove="1" noResize="1" noEditPoints="1" noAdjustHandles="1" noChangeArrowheads="1" noChangeShapeType="1" noTextEdit="1"/>
+          </p:cNvSpPr>
+          <p:nvPr>
+            <p:extLst>
+              <p:ext uri="{386F3935-93C4-4BCD-93E2-E3B085C9AB24}">
+                <p16:designElem xmlns:p16="http://schemas.microsoft.com/office/powerpoint/2015/main" val="1"/>
+              </p:ext>
+            </p:extLst>
+          </p:nvPr>
+        </p:nvSpPr>
+        <p:spPr>
+          <a:xfrm flipV="1">
+            <a:off x="7550402" y="2455479"/>
+            <a:ext cx="4083433" cy="4083433"/>
+          </a:xfrm>
+          <a:prstGeom prst="arc">
+            <a:avLst/>
+          </a:prstGeom>
+          <a:ln w="127000" cap="rnd">
+            <a:solidFill>
+              <a:schemeClr val="accent4"/>
+            </a:solidFill>
+            <a:prstDash val="dash"/>
+          </a:ln>
+        </p:spPr>
+        <p:style>
+          <a:lnRef idx="1">
+            <a:schemeClr val="accent1"/>
+          </a:lnRef>
+          <a:fillRef idx="0">
+            <a:schemeClr val="accent1"/>
+          </a:fillRef>
+          <a:effectRef idx="0">
+            <a:schemeClr val="accent1"/>
+          </a:effectRef>
+          <a:fontRef idx="minor">
+            <a:schemeClr val="tx1"/>
+          </a:fontRef>
+        </p:style>
+        <p:txBody>
+          <a:bodyPr rtlCol="0" anchor="ctr"/>
+          <a:lstStyle/>
+          <a:p>
+            <a:pPr algn="ctr"/>
+            <a:endParaRPr lang="en-US" dirty="0"/>
+          </a:p>
+        </p:txBody>
+      </p:sp>
+      <p:sp>
+        <p:nvSpPr>
+          <p:cNvPr id="3" name="Content Placeholder 2">
+            <a:extLst>
+              <a:ext uri="{FF2B5EF4-FFF2-40B4-BE49-F238E27FC236}">
+                <a16:creationId xmlns:a16="http://schemas.microsoft.com/office/drawing/2014/main" id="{19BE6953-44A8-E351-F8C5-9B2D6522B55D}"/>
+              </a:ext>
+            </a:extLst>
+          </p:cNvPr>
+          <p:cNvSpPr>
+            <a:spLocks noGrp="1"/>
+          </p:cNvSpPr>
+          <p:nvPr>
+            <p:ph idx="1"/>
+          </p:nvPr>
+        </p:nvSpPr>
+        <p:spPr>
+          <a:xfrm>
+            <a:off x="4447308" y="591344"/>
+            <a:ext cx="6906491" cy="5585619"/>
+          </a:xfrm>
+        </p:spPr>
+        <p:txBody>
+          <a:bodyPr anchor="ctr">
+            <a:normAutofit/>
+          </a:bodyPr>
+          <a:lstStyle/>
+          <a:p>
+            <a:pPr marL="0" indent="0">
+              <a:buNone/>
+            </a:pPr>
+            <a:r>
+              <a:rPr lang="en-US" dirty="0"/>
+              <a:t>Thank you</a:t>
+            </a:r>
+          </a:p>
+        </p:txBody>
+      </p:sp>
+    </p:spTree>
+    <p:extLst>
+      <p:ext uri="{BB962C8B-B14F-4D97-AF65-F5344CB8AC3E}">
+        <p14:creationId xmlns:p14="http://schemas.microsoft.com/office/powerpoint/2010/main" val="1409184322"/>
+      </p:ext>
+    </p:extLst>
+  </p:cSld>
+  <p:clrMapOvr>
+    <a:masterClrMapping/>
+  </p:clrMapOvr>
+</p:sld>
+</file>
+
 <file path=ppt/slides/slide2.xml><?xml version="1.0" encoding="utf-8"?>
 <p:sld xmlns:a="http://schemas.openxmlformats.org/drawingml/2006/main" xmlns:r="http://schemas.openxmlformats.org/officeDocument/2006/relationships" xmlns:p="http://schemas.openxmlformats.org/presentationml/2006/main">
   <p:cSld>
@@ -7925,23 +8742,9 @@
 <file path=ppt/slides/slide9.xml><?xml version="1.0" encoding="utf-8"?>
 <p:sld xmlns:a="http://schemas.openxmlformats.org/drawingml/2006/main" xmlns:r="http://schemas.openxmlformats.org/officeDocument/2006/relationships" xmlns:p="http://schemas.openxmlformats.org/presentationml/2006/main">
   <p:cSld>
-    <p:bg>
-      <p:bgPr>
-        <a:solidFill>
-          <a:schemeClr val="bg1"/>
-        </a:solidFill>
-        <a:effectLst/>
-      </p:bgPr>
-    </p:bg>
     <p:spTree>
       <p:nvGrpSpPr>
-        <p:cNvPr id="1" name="">
-          <a:extLst>
-            <a:ext uri="{FF2B5EF4-FFF2-40B4-BE49-F238E27FC236}">
-              <a16:creationId xmlns:a16="http://schemas.microsoft.com/office/drawing/2014/main" id="{4A8299C4-A57F-F76F-A252-0BDFCC66E676}"/>
-            </a:ext>
-          </a:extLst>
-        </p:cNvPr>
+        <p:cNvPr id="1" name=""/>
         <p:cNvGrpSpPr/>
         <p:nvPr/>
       </p:nvGrpSpPr>
@@ -7953,224 +8756,140 @@
           <a:chExt cx="0" cy="0"/>
         </a:xfrm>
       </p:grpSpPr>
-      <p:sp useBgFill="1">
-        <p:nvSpPr>
-          <p:cNvPr id="24" name="Rectangle 23">
-            <a:extLst>
-              <a:ext uri="{FF2B5EF4-FFF2-40B4-BE49-F238E27FC236}">
-                <a16:creationId xmlns:a16="http://schemas.microsoft.com/office/drawing/2014/main" id="{D79EAD09-A52B-3F40-20A0-992FD5B02C2D}"/>
-              </a:ext>
-              <a:ext uri="{C183D7F6-B498-43B3-948B-1728B52AA6E4}">
-                <adec:decorative xmlns:adec="http://schemas.microsoft.com/office/drawing/2017/decorative" val="1"/>
-              </a:ext>
-            </a:extLst>
-          </p:cNvPr>
-          <p:cNvSpPr>
-            <a:spLocks noGrp="1" noRot="1" noChangeAspect="1" noMove="1" noResize="1" noEditPoints="1" noAdjustHandles="1" noChangeArrowheads="1" noChangeShapeType="1" noTextEdit="1"/>
-          </p:cNvSpPr>
-          <p:nvPr>
-            <p:extLst>
-              <p:ext uri="{386F3935-93C4-4BCD-93E2-E3B085C9AB24}">
-                <p16:designElem xmlns:p16="http://schemas.microsoft.com/office/powerpoint/2015/main" val="1"/>
-              </p:ext>
-            </p:extLst>
-          </p:nvPr>
+      <p:sp>
+        <p:nvSpPr>
+          <p:cNvPr id="5" name="TextBox 4">
+            <a:extLst>
+              <a:ext uri="{FF2B5EF4-FFF2-40B4-BE49-F238E27FC236}">
+                <a16:creationId xmlns:a16="http://schemas.microsoft.com/office/drawing/2014/main" id="{C7CC2621-CD84-C051-182F-C0B593923FCE}"/>
+              </a:ext>
+            </a:extLst>
+          </p:cNvPr>
+          <p:cNvSpPr txBox="1"/>
+          <p:nvPr/>
         </p:nvSpPr>
         <p:spPr>
           <a:xfrm>
-            <a:off x="3048" y="4293"/>
-            <a:ext cx="12188952" cy="6858000"/>
+            <a:off x="1270000" y="778084"/>
+            <a:ext cx="6096000" cy="5078313"/>
           </a:xfrm>
           <a:prstGeom prst="rect">
             <a:avLst/>
           </a:prstGeom>
-          <a:ln>
-            <a:noFill/>
-          </a:ln>
+          <a:noFill/>
         </p:spPr>
-        <p:style>
-          <a:lnRef idx="2">
-            <a:schemeClr val="accent1">
-              <a:shade val="50000"/>
-            </a:schemeClr>
-          </a:lnRef>
-          <a:fillRef idx="1">
-            <a:schemeClr val="accent1"/>
-          </a:fillRef>
-          <a:effectRef idx="0">
-            <a:schemeClr val="accent1"/>
-          </a:effectRef>
-          <a:fontRef idx="minor">
-            <a:schemeClr val="lt1"/>
-          </a:fontRef>
-        </p:style>
-        <p:txBody>
-          <a:bodyPr rtlCol="0" anchor="ctr"/>
-          <a:lstStyle/>
-          <a:p>
-            <a:pPr algn="ctr"/>
-            <a:endParaRPr lang="en-US"/>
-          </a:p>
-        </p:txBody>
-      </p:sp>
-      <p:sp>
-        <p:nvSpPr>
-          <p:cNvPr id="25" name="Rectangle 24">
-            <a:extLst>
-              <a:ext uri="{FF2B5EF4-FFF2-40B4-BE49-F238E27FC236}">
-                <a16:creationId xmlns:a16="http://schemas.microsoft.com/office/drawing/2014/main" id="{E3C6766D-7230-6D6A-2178-AFEA6D3E8834}"/>
-              </a:ext>
-              <a:ext uri="{C183D7F6-B498-43B3-948B-1728B52AA6E4}">
-                <adec:decorative xmlns:adec="http://schemas.microsoft.com/office/drawing/2017/decorative" val="1"/>
-              </a:ext>
-            </a:extLst>
-          </p:cNvPr>
-          <p:cNvSpPr>
-            <a:spLocks noGrp="1" noRot="1" noChangeAspect="1" noMove="1" noResize="1" noEditPoints="1" noAdjustHandles="1" noChangeArrowheads="1" noChangeShapeType="1" noTextEdit="1"/>
-          </p:cNvSpPr>
-          <p:nvPr>
-            <p:extLst>
-              <p:ext uri="{386F3935-93C4-4BCD-93E2-E3B085C9AB24}">
-                <p16:designElem xmlns:p16="http://schemas.microsoft.com/office/powerpoint/2015/main" val="1"/>
-              </p:ext>
-            </p:extLst>
-          </p:nvPr>
-        </p:nvSpPr>
-        <p:spPr>
-          <a:xfrm>
-            <a:off x="0" y="-4"/>
-            <a:ext cx="4167268" cy="6858004"/>
-          </a:xfrm>
-          <a:prstGeom prst="rect">
-            <a:avLst/>
-          </a:prstGeom>
-          <a:solidFill>
-            <a:schemeClr val="accent2"/>
-          </a:solidFill>
-          <a:ln>
-            <a:noFill/>
-          </a:ln>
-        </p:spPr>
-        <p:style>
-          <a:lnRef idx="2">
-            <a:schemeClr val="accent1">
-              <a:shade val="50000"/>
-            </a:schemeClr>
-          </a:lnRef>
-          <a:fillRef idx="1">
-            <a:schemeClr val="accent1"/>
-          </a:fillRef>
-          <a:effectRef idx="0">
-            <a:schemeClr val="accent1"/>
-          </a:effectRef>
-          <a:fontRef idx="minor">
-            <a:schemeClr val="lt1"/>
-          </a:fontRef>
-        </p:style>
-        <p:txBody>
-          <a:bodyPr rtlCol="0" anchor="ctr"/>
-          <a:lstStyle/>
-          <a:p>
-            <a:pPr algn="ctr"/>
-            <a:endParaRPr lang="en-US"/>
-          </a:p>
-        </p:txBody>
-      </p:sp>
-      <p:sp>
-        <p:nvSpPr>
-          <p:cNvPr id="26" name="Arc 25">
-            <a:extLst>
-              <a:ext uri="{FF2B5EF4-FFF2-40B4-BE49-F238E27FC236}">
-                <a16:creationId xmlns:a16="http://schemas.microsoft.com/office/drawing/2014/main" id="{7098CF42-3639-BD0B-AB92-5E94C9F7FB6D}"/>
-              </a:ext>
-              <a:ext uri="{C183D7F6-B498-43B3-948B-1728B52AA6E4}">
-                <adec:decorative xmlns:adec="http://schemas.microsoft.com/office/drawing/2017/decorative" val="1"/>
-              </a:ext>
-            </a:extLst>
-          </p:cNvPr>
-          <p:cNvSpPr>
-            <a:spLocks noGrp="1" noRot="1" noChangeAspect="1" noMove="1" noResize="1" noEditPoints="1" noAdjustHandles="1" noChangeArrowheads="1" noChangeShapeType="1" noTextEdit="1"/>
-          </p:cNvSpPr>
-          <p:nvPr>
-            <p:extLst>
-              <p:ext uri="{386F3935-93C4-4BCD-93E2-E3B085C9AB24}">
-                <p16:designElem xmlns:p16="http://schemas.microsoft.com/office/powerpoint/2015/main" val="1"/>
-              </p:ext>
-            </p:extLst>
-          </p:nvPr>
-        </p:nvSpPr>
-        <p:spPr>
-          <a:xfrm flipV="1">
-            <a:off x="7550402" y="2455479"/>
-            <a:ext cx="4083433" cy="4083433"/>
-          </a:xfrm>
-          <a:prstGeom prst="arc">
-            <a:avLst/>
-          </a:prstGeom>
-          <a:ln w="127000" cap="rnd">
-            <a:solidFill>
-              <a:schemeClr val="accent4"/>
-            </a:solidFill>
-            <a:prstDash val="dash"/>
-          </a:ln>
-        </p:spPr>
-        <p:style>
-          <a:lnRef idx="1">
-            <a:schemeClr val="accent1"/>
-          </a:lnRef>
-          <a:fillRef idx="0">
-            <a:schemeClr val="accent1"/>
-          </a:fillRef>
-          <a:effectRef idx="0">
-            <a:schemeClr val="accent1"/>
-          </a:effectRef>
-          <a:fontRef idx="minor">
-            <a:schemeClr val="tx1"/>
-          </a:fontRef>
-        </p:style>
-        <p:txBody>
-          <a:bodyPr rtlCol="0" anchor="ctr"/>
-          <a:lstStyle/>
-          <a:p>
-            <a:pPr algn="ctr"/>
-            <a:endParaRPr lang="en-US" dirty="0"/>
-          </a:p>
-        </p:txBody>
-      </p:sp>
-      <p:sp>
-        <p:nvSpPr>
-          <p:cNvPr id="3" name="Content Placeholder 2">
-            <a:extLst>
-              <a:ext uri="{FF2B5EF4-FFF2-40B4-BE49-F238E27FC236}">
-                <a16:creationId xmlns:a16="http://schemas.microsoft.com/office/drawing/2014/main" id="{19BE6953-44A8-E351-F8C5-9B2D6522B55D}"/>
-              </a:ext>
-            </a:extLst>
-          </p:cNvPr>
-          <p:cNvSpPr>
-            <a:spLocks noGrp="1"/>
-          </p:cNvSpPr>
-          <p:nvPr>
-            <p:ph idx="1"/>
-          </p:nvPr>
-        </p:nvSpPr>
-        <p:spPr>
-          <a:xfrm>
-            <a:off x="4447308" y="591344"/>
-            <a:ext cx="6906491" cy="5585619"/>
-          </a:xfrm>
-        </p:spPr>
-        <p:txBody>
-          <a:bodyPr anchor="ctr">
-            <a:normAutofit/>
+        <p:txBody>
+          <a:bodyPr wrap="square">
+            <a:spAutoFit/>
           </a:bodyPr>
           <a:lstStyle/>
           <a:p>
-            <a:pPr marL="0" indent="0">
-              <a:buNone/>
-            </a:pPr>
             <a:r>
               <a:rPr lang="en-US" dirty="0"/>
-              <a:t>Thank you</a:t>
+              <a:t>📊 Checking AKS agent status...</a:t>
+            </a:r>
+          </a:p>
+          <a:p>
+            <a:endParaRPr lang="en-US" dirty="0"/>
+          </a:p>
+          <a:p>
+            <a:r>
+              <a:rPr lang="en-US" dirty="0"/>
+              <a:t>✅ Helm Release: deployed</a:t>
+            </a:r>
+          </a:p>
+          <a:p>
+            <a:endParaRPr lang="en-US" dirty="0"/>
+          </a:p>
+          <a:p>
+            <a:r>
+              <a:rPr lang="en-US" dirty="0"/>
+              <a:t>📦 Deployments:</a:t>
+            </a:r>
+          </a:p>
+          <a:p>
+            <a:r>
+              <a:rPr lang="en-US" dirty="0"/>
+              <a:t>  • </a:t>
+            </a:r>
+            <a:r>
+              <a:rPr lang="en-US" dirty="0" err="1"/>
+              <a:t>aks</a:t>
+            </a:r>
+            <a:r>
+              <a:rPr lang="en-US" dirty="0"/>
+              <a:t>-agent: 1/1 ready</a:t>
+            </a:r>
+          </a:p>
+          <a:p>
+            <a:r>
+              <a:rPr lang="en-US" dirty="0"/>
+              <a:t>  • </a:t>
+            </a:r>
+            <a:r>
+              <a:rPr lang="en-US" dirty="0" err="1"/>
+              <a:t>aks-mcp</a:t>
+            </a:r>
+            <a:r>
+              <a:rPr lang="en-US" dirty="0"/>
+              <a:t>: 1/1 ready</a:t>
+            </a:r>
+          </a:p>
+          <a:p>
+            <a:endParaRPr lang="en-US" dirty="0"/>
+          </a:p>
+          <a:p>
+            <a:r>
+              <a:rPr lang="en-US" dirty="0"/>
+              <a:t>🐳 Pods:</a:t>
+            </a:r>
+          </a:p>
+          <a:p>
+            <a:r>
+              <a:rPr lang="en-US" dirty="0"/>
+              <a:t>  • aks-agent-74f6ccff98-4qc9h: Running ✓</a:t>
+            </a:r>
+          </a:p>
+          <a:p>
+            <a:r>
+              <a:rPr lang="en-US" dirty="0"/>
+              <a:t>  • aks-mcp-58d89c588c-smf6x: Running ✓</a:t>
+            </a:r>
+          </a:p>
+          <a:p>
+            <a:endParaRPr lang="en-US" dirty="0"/>
+          </a:p>
+          <a:p>
+            <a:r>
+              <a:rPr lang="en-US" dirty="0"/>
+              <a:t>📋 LLM Configurations:</a:t>
+            </a:r>
+          </a:p>
+          <a:p>
+            <a:r>
+              <a:rPr lang="en-US" dirty="0"/>
+              <a:t>  • azure/gpt-5.2-chat</a:t>
+            </a:r>
+          </a:p>
+          <a:p>
+            <a:r>
+              <a:rPr lang="en-US" dirty="0"/>
+              <a:t>    API Base: https://coe-appinv-resource.openai.azure.com/</a:t>
+            </a:r>
+          </a:p>
+          <a:p>
+            <a:r>
+              <a:rPr lang="en-US" dirty="0"/>
+              <a:t>    API Version: 2024-12-01-preview</a:t>
+            </a:r>
+          </a:p>
+          <a:p>
+            <a:endParaRPr lang="en-US" dirty="0"/>
+          </a:p>
+          <a:p>
+            <a:r>
+              <a:rPr lang="en-US" dirty="0"/>
+              <a:t>✅ AKS agent is ready and running!</a:t>
             </a:r>
           </a:p>
         </p:txBody>
@@ -8178,7 +8897,7 @@
     </p:spTree>
     <p:extLst>
       <p:ext uri="{BB962C8B-B14F-4D97-AF65-F5344CB8AC3E}">
-        <p14:creationId xmlns:p14="http://schemas.microsoft.com/office/powerpoint/2010/main" val="1409184322"/>
+        <p14:creationId xmlns:p14="http://schemas.microsoft.com/office/powerpoint/2010/main" val="1002164974"/>
       </p:ext>
     </p:extLst>
   </p:cSld>

</xml_diff>